<commit_message>
Update presentation with title slide
Co-Authored-By: Claude Sonnet 4.6 <noreply@anthropic.com>
</commit_message>
<xml_diff>
--- a/soc-triage-presentation.pptx
+++ b/soc-triage-presentation.pptx
@@ -4,17 +4,17 @@
   <p:sldMasterIdLst>
     <p:sldMasterId id="2147483648" r:id="rId1"/>
   </p:sldMasterIdLst>
-  <p:sldIdLst>
-    <p:sldId id="256" r:id="rId2"/>
-    <p:sldId id="257" r:id="rId3"/>
-    <p:sldId id="258" r:id="rId4"/>
-    <p:sldId id="259" r:id="rId5"/>
-    <p:sldId id="260" r:id="rId6"/>
-  </p:sldIdLst>
   <p:notesMasterIdLst>
     <p:notesMasterId r:id="rId7"/>
   </p:notesMasterIdLst>
-  <p:sldSz cx="9144000" cy="5143500"/>
+  <p:sldIdLst>
+    <p:sldId id="261" r:id="rId2"/>
+    <p:sldId id="256" r:id="rId3"/>
+    <p:sldId id="257" r:id="rId4"/>
+    <p:sldId id="258" r:id="rId5"/>
+    <p:sldId id="259" r:id="rId6"/>
+  </p:sldIdLst>
+  <p:sldSz cx="9144000" cy="5143500" type="screen16x9"/>
   <p:notesSz cx="5143500" cy="9144000"/>
   <p:defaultTextStyle>
     <a:lvl1pPr marL="0" algn="l" defTabSz="914400" rtl="0" eaLnBrk="1" latinLnBrk="0" hangingPunct="1">
@@ -108,7 +108,188 @@
       </a:defRPr>
     </a:lvl9pPr>
   </p:defaultTextStyle>
+  <p:extLst>
+    <p:ext uri="{EFAFB233-063F-42B5-8137-9DF3F51BA10A}">
+      <p15:sldGuideLst xmlns:p15="http://schemas.microsoft.com/office/powerpoint/2012/main"/>
+    </p:ext>
+  </p:extLst>
 </p:presentation>
+</file>
+
+<file path=ppt/revisionInfo.xml><?xml version="1.0" encoding="utf-8"?>
+<p1510:revInfo xmlns:a="http://schemas.openxmlformats.org/drawingml/2006/main" xmlns:r="http://schemas.openxmlformats.org/officeDocument/2006/relationships" xmlns:p1510="http://schemas.microsoft.com/office/powerpoint/2015/10/main">
+  <p1510:revLst>
+    <p1510:client id="{E86BAE9F-E203-2847-8B72-F681DA40D161}" v="10" dt="2026-05-13T01:44:46.844"/>
+  </p1510:revLst>
+</p1510:revInfo>
+</file>
+
+<file path=ppt/changesInfos/changesInfo1.xml><?xml version="1.0" encoding="utf-8"?>
+<pc:chgInfo xmlns:a="http://schemas.openxmlformats.org/drawingml/2006/main" xmlns:r="http://schemas.openxmlformats.org/officeDocument/2006/relationships" xmlns:ac="http://schemas.microsoft.com/office/drawing/2013/main/command" xmlns:pc="http://schemas.microsoft.com/office/powerpoint/2013/main/command">
+  <pc:docChgLst>
+    <pc:chgData name="Devin Ramotar" userId="49643e84-c1d2-4c3d-b1a9-add7432efeed" providerId="ADAL" clId="{7500DFD5-A196-56B8-87B4-5D018B1D0FE3}"/>
+    <pc:docChg chg="undo custSel addSld delSld modSld sldOrd">
+      <pc:chgData name="Devin Ramotar" userId="49643e84-c1d2-4c3d-b1a9-add7432efeed" providerId="ADAL" clId="{7500DFD5-A196-56B8-87B4-5D018B1D0FE3}" dt="2026-05-13T01:44:53.086" v="56"/>
+      <pc:docMkLst>
+        <pc:docMk/>
+      </pc:docMkLst>
+      <pc:sldChg chg="modSp mod">
+        <pc:chgData name="Devin Ramotar" userId="49643e84-c1d2-4c3d-b1a9-add7432efeed" providerId="ADAL" clId="{7500DFD5-A196-56B8-87B4-5D018B1D0FE3}" dt="2026-05-10T21:11:43.076" v="7" actId="20577"/>
+        <pc:sldMkLst>
+          <pc:docMk/>
+          <pc:sldMk cId="0" sldId="256"/>
+        </pc:sldMkLst>
+        <pc:spChg chg="mod">
+          <ac:chgData name="Devin Ramotar" userId="49643e84-c1d2-4c3d-b1a9-add7432efeed" providerId="ADAL" clId="{7500DFD5-A196-56B8-87B4-5D018B1D0FE3}" dt="2026-05-10T21:11:43.076" v="7" actId="20577"/>
+          <ac:spMkLst>
+            <pc:docMk/>
+            <pc:sldMk cId="0" sldId="256"/>
+            <ac:spMk id="4" creationId="{00000000-0000-0000-0000-000000000000}"/>
+          </ac:spMkLst>
+        </pc:spChg>
+      </pc:sldChg>
+      <pc:sldChg chg="modSp mod">
+        <pc:chgData name="Devin Ramotar" userId="49643e84-c1d2-4c3d-b1a9-add7432efeed" providerId="ADAL" clId="{7500DFD5-A196-56B8-87B4-5D018B1D0FE3}" dt="2026-05-11T00:06:32.765" v="8" actId="20577"/>
+        <pc:sldMkLst>
+          <pc:docMk/>
+          <pc:sldMk cId="0" sldId="258"/>
+        </pc:sldMkLst>
+        <pc:spChg chg="mod">
+          <ac:chgData name="Devin Ramotar" userId="49643e84-c1d2-4c3d-b1a9-add7432efeed" providerId="ADAL" clId="{7500DFD5-A196-56B8-87B4-5D018B1D0FE3}" dt="2026-05-11T00:06:32.765" v="8" actId="20577"/>
+          <ac:spMkLst>
+            <pc:docMk/>
+            <pc:sldMk cId="0" sldId="258"/>
+            <ac:spMk id="11" creationId="{00000000-0000-0000-0000-000000000000}"/>
+          </ac:spMkLst>
+        </pc:spChg>
+        <pc:spChg chg="mod">
+          <ac:chgData name="Devin Ramotar" userId="49643e84-c1d2-4c3d-b1a9-add7432efeed" providerId="ADAL" clId="{7500DFD5-A196-56B8-87B4-5D018B1D0FE3}" dt="2026-05-10T21:05:54.464" v="1" actId="20577"/>
+          <ac:spMkLst>
+            <pc:docMk/>
+            <pc:sldMk cId="0" sldId="258"/>
+            <ac:spMk id="39" creationId="{00000000-0000-0000-0000-000000000000}"/>
+          </ac:spMkLst>
+        </pc:spChg>
+      </pc:sldChg>
+      <pc:sldChg chg="addSp delSp modSp mod">
+        <pc:chgData name="Devin Ramotar" userId="49643e84-c1d2-4c3d-b1a9-add7432efeed" providerId="ADAL" clId="{7500DFD5-A196-56B8-87B4-5D018B1D0FE3}" dt="2026-05-13T01:44:53.086" v="56"/>
+        <pc:sldMkLst>
+          <pc:docMk/>
+          <pc:sldMk cId="0" sldId="259"/>
+        </pc:sldMkLst>
+        <pc:spChg chg="mod">
+          <ac:chgData name="Devin Ramotar" userId="49643e84-c1d2-4c3d-b1a9-add7432efeed" providerId="ADAL" clId="{7500DFD5-A196-56B8-87B4-5D018B1D0FE3}" dt="2026-05-13T01:44:50.200" v="54" actId="20577"/>
+          <ac:spMkLst>
+            <pc:docMk/>
+            <pc:sldMk cId="0" sldId="259"/>
+            <ac:spMk id="5" creationId="{00000000-0000-0000-0000-000000000000}"/>
+          </ac:spMkLst>
+        </pc:spChg>
+        <pc:spChg chg="mod">
+          <ac:chgData name="Devin Ramotar" userId="49643e84-c1d2-4c3d-b1a9-add7432efeed" providerId="ADAL" clId="{7500DFD5-A196-56B8-87B4-5D018B1D0FE3}" dt="2026-05-13T01:33:04.526" v="16" actId="1076"/>
+          <ac:spMkLst>
+            <pc:docMk/>
+            <pc:sldMk cId="0" sldId="259"/>
+            <ac:spMk id="11" creationId="{00000000-0000-0000-0000-000000000000}"/>
+          </ac:spMkLst>
+        </pc:spChg>
+        <pc:spChg chg="mod">
+          <ac:chgData name="Devin Ramotar" userId="49643e84-c1d2-4c3d-b1a9-add7432efeed" providerId="ADAL" clId="{7500DFD5-A196-56B8-87B4-5D018B1D0FE3}" dt="2026-05-11T00:15:47.750" v="10" actId="1076"/>
+          <ac:spMkLst>
+            <pc:docMk/>
+            <pc:sldMk cId="0" sldId="259"/>
+            <ac:spMk id="42" creationId="{00000000-0000-0000-0000-000000000000}"/>
+          </ac:spMkLst>
+        </pc:spChg>
+        <pc:spChg chg="mod">
+          <ac:chgData name="Devin Ramotar" userId="49643e84-c1d2-4c3d-b1a9-add7432efeed" providerId="ADAL" clId="{7500DFD5-A196-56B8-87B4-5D018B1D0FE3}" dt="2026-05-11T00:16:20.137" v="12" actId="1076"/>
+          <ac:spMkLst>
+            <pc:docMk/>
+            <pc:sldMk cId="0" sldId="259"/>
+            <ac:spMk id="66" creationId="{00000000-0000-0000-0000-000000000000}"/>
+          </ac:spMkLst>
+        </pc:spChg>
+        <pc:spChg chg="mod">
+          <ac:chgData name="Devin Ramotar" userId="49643e84-c1d2-4c3d-b1a9-add7432efeed" providerId="ADAL" clId="{7500DFD5-A196-56B8-87B4-5D018B1D0FE3}" dt="2026-05-11T00:16:20.137" v="12" actId="1076"/>
+          <ac:spMkLst>
+            <pc:docMk/>
+            <pc:sldMk cId="0" sldId="259"/>
+            <ac:spMk id="67" creationId="{00000000-0000-0000-0000-000000000000}"/>
+          </ac:spMkLst>
+        </pc:spChg>
+        <pc:spChg chg="mod">
+          <ac:chgData name="Devin Ramotar" userId="49643e84-c1d2-4c3d-b1a9-add7432efeed" providerId="ADAL" clId="{7500DFD5-A196-56B8-87B4-5D018B1D0FE3}" dt="2026-05-11T00:16:20.137" v="12" actId="1076"/>
+          <ac:spMkLst>
+            <pc:docMk/>
+            <pc:sldMk cId="0" sldId="259"/>
+            <ac:spMk id="68" creationId="{00000000-0000-0000-0000-000000000000}"/>
+          </ac:spMkLst>
+        </pc:spChg>
+        <pc:spChg chg="mod">
+          <ac:chgData name="Devin Ramotar" userId="49643e84-c1d2-4c3d-b1a9-add7432efeed" providerId="ADAL" clId="{7500DFD5-A196-56B8-87B4-5D018B1D0FE3}" dt="2026-05-11T00:16:26.106" v="14" actId="1076"/>
+          <ac:spMkLst>
+            <pc:docMk/>
+            <pc:sldMk cId="0" sldId="259"/>
+            <ac:spMk id="69" creationId="{00000000-0000-0000-0000-000000000000}"/>
+          </ac:spMkLst>
+        </pc:spChg>
+        <pc:spChg chg="mod">
+          <ac:chgData name="Devin Ramotar" userId="49643e84-c1d2-4c3d-b1a9-add7432efeed" providerId="ADAL" clId="{7500DFD5-A196-56B8-87B4-5D018B1D0FE3}" dt="2026-05-11T00:16:20.137" v="12" actId="1076"/>
+          <ac:spMkLst>
+            <pc:docMk/>
+            <pc:sldMk cId="0" sldId="259"/>
+            <ac:spMk id="70" creationId="{00000000-0000-0000-0000-000000000000}"/>
+          </ac:spMkLst>
+        </pc:spChg>
+        <pc:spChg chg="add del mod">
+          <ac:chgData name="Devin Ramotar" userId="49643e84-c1d2-4c3d-b1a9-add7432efeed" providerId="ADAL" clId="{7500DFD5-A196-56B8-87B4-5D018B1D0FE3}" dt="2026-05-13T01:44:53.086" v="56"/>
+          <ac:spMkLst>
+            <pc:docMk/>
+            <pc:sldMk cId="0" sldId="259"/>
+            <ac:spMk id="72" creationId="{5016B11A-2FE2-BE3D-0D7D-613F5AE3C3C4}"/>
+          </ac:spMkLst>
+        </pc:spChg>
+        <pc:picChg chg="add mod">
+          <ac:chgData name="Devin Ramotar" userId="49643e84-c1d2-4c3d-b1a9-add7432efeed" providerId="ADAL" clId="{7500DFD5-A196-56B8-87B4-5D018B1D0FE3}" dt="2026-05-13T01:38:30.225" v="20"/>
+          <ac:picMkLst>
+            <pc:docMk/>
+            <pc:sldMk cId="0" sldId="259"/>
+            <ac:picMk id="71" creationId="{72A57BD6-66C9-BF89-79B3-442EDCE19AF7}"/>
+          </ac:picMkLst>
+        </pc:picChg>
+      </pc:sldChg>
+      <pc:sldChg chg="add del ord setBg">
+        <pc:chgData name="Devin Ramotar" userId="49643e84-c1d2-4c3d-b1a9-add7432efeed" providerId="ADAL" clId="{7500DFD5-A196-56B8-87B4-5D018B1D0FE3}" dt="2026-05-13T01:43:52.507" v="30" actId="2696"/>
+        <pc:sldMkLst>
+          <pc:docMk/>
+          <pc:sldMk cId="0" sldId="260"/>
+        </pc:sldMkLst>
+      </pc:sldChg>
+      <pc:sldChg chg="new del">
+        <pc:chgData name="Devin Ramotar" userId="49643e84-c1d2-4c3d-b1a9-add7432efeed" providerId="ADAL" clId="{7500DFD5-A196-56B8-87B4-5D018B1D0FE3}" dt="2026-05-13T01:35:34.558" v="18" actId="2696"/>
+        <pc:sldMkLst>
+          <pc:docMk/>
+          <pc:sldMk cId="2302361615" sldId="260"/>
+        </pc:sldMkLst>
+      </pc:sldChg>
+      <pc:sldChg chg="modSp add mod setBg">
+        <pc:chgData name="Devin Ramotar" userId="49643e84-c1d2-4c3d-b1a9-add7432efeed" providerId="ADAL" clId="{7500DFD5-A196-56B8-87B4-5D018B1D0FE3}" dt="2026-05-13T01:44:37.263" v="52" actId="20577"/>
+        <pc:sldMkLst>
+          <pc:docMk/>
+          <pc:sldMk cId="0" sldId="261"/>
+        </pc:sldMkLst>
+        <pc:spChg chg="mod">
+          <ac:chgData name="Devin Ramotar" userId="49643e84-c1d2-4c3d-b1a9-add7432efeed" providerId="ADAL" clId="{7500DFD5-A196-56B8-87B4-5D018B1D0FE3}" dt="2026-05-13T01:44:37.263" v="52" actId="20577"/>
+          <ac:spMkLst>
+            <pc:docMk/>
+            <pc:sldMk cId="0" sldId="261"/>
+            <ac:spMk id="8" creationId="{00000000-0000-0000-0000-000000000000}"/>
+          </ac:spMkLst>
+        </pc:spChg>
+      </pc:sldChg>
+    </pc:docChg>
+  </pc:docChgLst>
+</pc:chgInfo>
 </file>
 
 <file path=ppt/notesMasters/notesMaster1.xml><?xml version="1.0" encoding="utf-8"?>
@@ -133,234 +314,10 @@
           <a:chExt cx="0" cy="0"/>
         </a:xfrm>
       </p:grpSpPr>
-      <p:sp>
-        <p:nvSpPr>
-          <p:cNvPr id="2" name="Header Placeholder 1"/>
-          <p:cNvSpPr>
-            <a:spLocks noGrp="1"/>
-          </p:cNvSpPr>
-          <p:nvPr>
-            <p:ph type="hdr" sz="quarter"/>
-          </p:nvPr>
-        </p:nvSpPr>
-        <p:spPr>
-          <a:xfrm>
-            <a:off x="0" y="0"/>
-            <a:ext cx="2971800" cy="458788"/>
-          </a:xfrm>
-          <a:prstGeom prst="rect">
-            <a:avLst/>
-          </a:prstGeom>
-        </p:spPr>
-        <p:txBody>
-          <a:bodyPr vert="horz" lIns="91440" tIns="45720" rIns="91440" bIns="45720" rtlCol="0"/>
-          <a:lstStyle>
-            <a:lvl1pPr algn="l">
-              <a:defRPr sz="1200"/>
-            </a:lvl1pPr>
-          </a:lstStyle>
-          <a:p>
-            <a:endParaRPr lang="en-US"/>
-          </a:p>
-        </p:txBody>
-      </p:sp>
-      <p:sp>
-        <p:nvSpPr>
-          <p:cNvPr id="3" name="Date Placeholder 2"/>
-          <p:cNvSpPr>
-            <a:spLocks noGrp="1"/>
-          </p:cNvSpPr>
-          <p:nvPr>
-            <p:ph type="dt" idx="1"/>
-          </p:nvPr>
-        </p:nvSpPr>
-        <p:spPr>
-          <a:xfrm>
-            <a:off x="3884613" y="0"/>
-            <a:ext cx="2971800" cy="458788"/>
-          </a:xfrm>
-          <a:prstGeom prst="rect">
-            <a:avLst/>
-          </a:prstGeom>
-        </p:spPr>
-        <p:txBody>
-          <a:bodyPr vert="horz" lIns="91440" tIns="45720" rIns="91440" bIns="45720" rtlCol="0"/>
-          <a:lstStyle>
-            <a:lvl1pPr algn="r">
-              <a:defRPr sz="1200"/>
-            </a:lvl1pPr>
-          </a:lstStyle>
-          <a:p>
-            <a:fld id="{5282F153-3F37-0F45-9E97-73ACFA13230C}" type="datetimeFigureOut">
-              <a:rPr lang="en-US"/>
-              <a:t>7/23/19</a:t>
-            </a:fld>
-            <a:endParaRPr lang="en-US"/>
-          </a:p>
-        </p:txBody>
-      </p:sp>
-      <p:sp>
-        <p:nvSpPr>
-          <p:cNvPr id="4" name="Slide Image Placeholder 3"/>
-          <p:cNvSpPr>
-            <a:spLocks noGrp="1" noRot="1" noChangeAspect="1"/>
-          </p:cNvSpPr>
-          <p:nvPr>
-            <p:ph type="sldImg" idx="2"/>
-          </p:nvPr>
-        </p:nvSpPr>
-        <p:spPr>
-          <a:xfrm>
-            <a:off x="685800" y="1143000"/>
-            <a:ext cx="5486400" cy="3086100"/>
-          </a:xfrm>
-          <a:prstGeom prst="rect">
-            <a:avLst/>
-          </a:prstGeom>
-          <a:noFill/>
-          <a:ln w="12700">
-            <a:solidFill>
-              <a:prstClr val="black"/>
-            </a:solidFill>
-          </a:ln>
-        </p:spPr>
-        <p:txBody>
-          <a:bodyPr vert="horz" lIns="91440" tIns="45720" rIns="91440" bIns="45720" rtlCol="0" anchor="ctr"/>
-          <a:lstStyle/>
-          <a:p>
-            <a:endParaRPr lang="en-US"/>
-          </a:p>
-        </p:txBody>
-      </p:sp>
-      <p:sp>
-        <p:nvSpPr>
-          <p:cNvPr id="5" name="Notes Placeholder 4"/>
-          <p:cNvSpPr>
-            <a:spLocks noGrp="1"/>
-          </p:cNvSpPr>
-          <p:nvPr>
-            <p:ph type="body" sz="quarter" idx="3"/>
-          </p:nvPr>
-        </p:nvSpPr>
-        <p:spPr>
-          <a:xfrm>
-            <a:off x="685800" y="4400550"/>
-            <a:ext cx="5486400" cy="3600450"/>
-          </a:xfrm>
-          <a:prstGeom prst="rect">
-            <a:avLst/>
-          </a:prstGeom>
-        </p:spPr>
-        <p:txBody>
-          <a:bodyPr vert="horz" lIns="91440" tIns="45720" rIns="91440" bIns="45720" rtlCol="0"/>
-          <a:lstStyle/>
-          <a:p>
-            <a:pPr lvl="0"/>
-            <a:r>
-              <a:rPr lang="en-US"/>
-              <a:t>Click to edit Master text styles</a:t>
-            </a:r>
-          </a:p>
-          <a:p>
-            <a:pPr lvl="1"/>
-            <a:r>
-              <a:rPr lang="en-US"/>
-              <a:t>Second level</a:t>
-            </a:r>
-          </a:p>
-          <a:p>
-            <a:pPr lvl="2"/>
-            <a:r>
-              <a:rPr lang="en-US"/>
-              <a:t>Third level</a:t>
-            </a:r>
-          </a:p>
-          <a:p>
-            <a:pPr lvl="3"/>
-            <a:r>
-              <a:rPr lang="en-US"/>
-              <a:t>Fourth level</a:t>
-            </a:r>
-          </a:p>
-          <a:p>
-            <a:pPr lvl="4"/>
-            <a:r>
-              <a:rPr lang="en-US"/>
-              <a:t>Fifth level</a:t>
-            </a:r>
-          </a:p>
-        </p:txBody>
-      </p:sp>
-      <p:sp>
-        <p:nvSpPr>
-          <p:cNvPr id="6" name="Footer Placeholder 5"/>
-          <p:cNvSpPr>
-            <a:spLocks noGrp="1"/>
-          </p:cNvSpPr>
-          <p:nvPr>
-            <p:ph type="ftr" sz="quarter" idx="4"/>
-          </p:nvPr>
-        </p:nvSpPr>
-        <p:spPr>
-          <a:xfrm>
-            <a:off x="0" y="8685213"/>
-            <a:ext cx="2971800" cy="458787"/>
-          </a:xfrm>
-          <a:prstGeom prst="rect">
-            <a:avLst/>
-          </a:prstGeom>
-        </p:spPr>
-        <p:txBody>
-          <a:bodyPr vert="horz" lIns="91440" tIns="45720" rIns="91440" bIns="45720" rtlCol="0" anchor="b"/>
-          <a:lstStyle>
-            <a:lvl1pPr algn="l">
-              <a:defRPr sz="1200"/>
-            </a:lvl1pPr>
-          </a:lstStyle>
-          <a:p>
-            <a:endParaRPr lang="en-US"/>
-          </a:p>
-        </p:txBody>
-      </p:sp>
-      <p:sp>
-        <p:nvSpPr>
-          <p:cNvPr id="7" name="Slide Number Placeholder 6"/>
-          <p:cNvSpPr>
-            <a:spLocks noGrp="1"/>
-          </p:cNvSpPr>
-          <p:nvPr>
-            <p:ph type="sldNum" sz="quarter" idx="5"/>
-          </p:nvPr>
-        </p:nvSpPr>
-        <p:spPr>
-          <a:xfrm>
-            <a:off x="3884613" y="8685213"/>
-            <a:ext cx="2971800" cy="458787"/>
-          </a:xfrm>
-          <a:prstGeom prst="rect">
-            <a:avLst/>
-          </a:prstGeom>
-        </p:spPr>
-        <p:txBody>
-          <a:bodyPr vert="horz" lIns="91440" tIns="45720" rIns="91440" bIns="45720" rtlCol="0" anchor="b"/>
-          <a:lstStyle>
-            <a:lvl1pPr algn="r">
-              <a:defRPr sz="1200"/>
-            </a:lvl1pPr>
-          </a:lstStyle>
-          <a:p>
-            <a:fld id="{CE5E9CC1-C706-0F49-92D6-E571CC5EEA8F}" type="slidenum">
-              <a:rPr lang="en-US"/>
-              <a:t>‹#›</a:t>
-            </a:fld>
-            <a:endParaRPr lang="en-US"/>
-          </a:p>
-        </p:txBody>
-      </p:sp>
     </p:spTree>
     <p:extLst>
       <p:ext uri="{BB962C8B-B14F-4D97-AF65-F5344CB8AC3E}">
-        <p14:creationId xmlns:p14="http://schemas.microsoft.com/office/powerpoint/2010/main" val="1024086991"/>
+        <p14:creationId xmlns:p14="http://schemas.microsoft.com/office/powerpoint/2010/main" val="2385925920"/>
       </p:ext>
     </p:extLst>
   </p:cSld>
@@ -504,10 +461,6 @@
           <a:bodyPr/>
           <a:lstStyle/>
           <a:p>
-            <a:r>
-              <a:rPr lang="en-US" dirty="0"/>
-              <a:t/>
-            </a:r>
             <a:endParaRPr lang="en-US" dirty="0"/>
           </a:p>
         </p:txBody>
@@ -592,10 +545,6 @@
           <a:bodyPr/>
           <a:lstStyle/>
           <a:p>
-            <a:r>
-              <a:rPr lang="en-US" dirty="0"/>
-              <a:t/>
-            </a:r>
             <a:endParaRPr lang="en-US" dirty="0"/>
           </a:p>
         </p:txBody>
@@ -680,10 +629,6 @@
           <a:bodyPr/>
           <a:lstStyle/>
           <a:p>
-            <a:r>
-              <a:rPr lang="en-US" dirty="0"/>
-              <a:t/>
-            </a:r>
             <a:endParaRPr lang="en-US" dirty="0"/>
           </a:p>
         </p:txBody>
@@ -768,10 +713,6 @@
           <a:bodyPr/>
           <a:lstStyle/>
           <a:p>
-            <a:r>
-              <a:rPr lang="en-US" dirty="0"/>
-              <a:t/>
-            </a:r>
             <a:endParaRPr lang="en-US" dirty="0"/>
           </a:p>
         </p:txBody>
@@ -856,10 +797,6 @@
           <a:bodyPr/>
           <a:lstStyle/>
           <a:p>
-            <a:r>
-              <a:rPr lang="en-US" dirty="0"/>
-              <a:t/>
-            </a:r>
             <a:endParaRPr lang="en-US" dirty="0"/>
           </a:p>
         </p:txBody>
@@ -933,6 +870,11 @@
 <file path=ppt/slideMasters/slideMaster1.xml><?xml version="1.0" encoding="utf-8"?>
 <p:sldMaster xmlns:a="http://schemas.openxmlformats.org/drawingml/2006/main" xmlns:r="http://schemas.openxmlformats.org/officeDocument/2006/relationships" xmlns:p="http://schemas.openxmlformats.org/presentationml/2006/main">
   <p:cSld>
+    <p:bg>
+      <p:bgRef idx="1001">
+        <a:schemeClr val="bg1"/>
+      </p:bgRef>
+    </p:bg>
     <p:spTree>
       <p:nvGrpSpPr>
         <p:cNvPr id="1" name=""/>
@@ -1209,12 +1151,13 @@
 
 <file path=ppt/slides/slide1.xml><?xml version="1.0" encoding="utf-8"?>
 <p:sld xmlns:a="http://schemas.openxmlformats.org/drawingml/2006/main" xmlns:r="http://schemas.openxmlformats.org/officeDocument/2006/relationships" xmlns:p="http://schemas.openxmlformats.org/presentationml/2006/main">
-  <p:cSld name="Slide 1">
+  <p:cSld>
     <p:bg>
       <p:bgPr>
         <a:solidFill>
-          <a:srgbClr val="0F1923"/>
+          <a:srgbClr val="051626"/>
         </a:solidFill>
+        <a:effectLst/>
       </p:bgPr>
     </p:bg>
     <p:spTree>
@@ -1255,6 +1198,13 @@
             <a:prstDash val="solid"/>
           </a:ln>
         </p:spPr>
+        <p:txBody>
+          <a:bodyPr/>
+          <a:lstStyle/>
+          <a:p>
+            <a:endParaRPr lang="en-US"/>
+          </a:p>
+        </p:txBody>
       </p:sp>
       <p:sp>
         <p:nvSpPr>
@@ -1280,6 +1230,13 @@
             <a:prstDash val="solid"/>
           </a:ln>
         </p:spPr>
+        <p:txBody>
+          <a:bodyPr/>
+          <a:lstStyle/>
+          <a:p>
+            <a:endParaRPr lang="en-US"/>
+          </a:p>
+        </p:txBody>
       </p:sp>
       <p:sp>
         <p:nvSpPr>
@@ -1305,6 +1262,13 @@
             <a:prstDash val="solid"/>
           </a:ln>
         </p:spPr>
+        <p:txBody>
+          <a:bodyPr/>
+          <a:lstStyle/>
+          <a:p>
+            <a:endParaRPr lang="en-US"/>
+          </a:p>
+        </p:txBody>
       </p:sp>
       <p:sp>
         <p:nvSpPr>
@@ -1330,6 +1294,13 @@
             <a:prstDash val="solid"/>
           </a:ln>
         </p:spPr>
+        <p:txBody>
+          <a:bodyPr/>
+          <a:lstStyle/>
+          <a:p>
+            <a:endParaRPr lang="en-US"/>
+          </a:p>
+        </p:txBody>
       </p:sp>
       <p:sp>
         <p:nvSpPr>
@@ -1352,7 +1323,7 @@
           <a:bodyPr wrap="square" lIns="0" tIns="0" rIns="0" bIns="0" rtlCol="0" anchor="ctr"/>
           <a:lstStyle/>
           <a:p>
-            <a:pPr algn="ctr" indent="0" marL="0">
+            <a:pPr marL="0" indent="0" algn="ctr">
               <a:buNone/>
             </a:pPr>
             <a:r>
@@ -1388,7 +1359,7 @@
           <a:bodyPr wrap="square" lIns="0" tIns="0" rIns="0" bIns="0" rtlCol="0" anchor="ctr"/>
           <a:lstStyle/>
           <a:p>
-            <a:pPr algn="ctr" indent="0" marL="0">
+            <a:pPr marL="0" indent="0" algn="ctr">
               <a:buNone/>
             </a:pPr>
             <a:r>
@@ -1427,7 +1398,7 @@
           <a:bodyPr wrap="square" lIns="0" tIns="0" rIns="0" bIns="0" rtlCol="0" anchor="ctr"/>
           <a:lstStyle/>
           <a:p>
-            <a:pPr algn="ctr" indent="0" marL="0">
+            <a:pPr marL="0" indent="0" algn="ctr">
               <a:buNone/>
             </a:pPr>
             <a:r>
@@ -1439,7 +1410,7 @@
                 <a:ea typeface="Calibri" pitchFamily="34" charset="-122"/>
                 <a:cs typeface="Calibri" pitchFamily="34" charset="-120"/>
               </a:rPr>
-              <a:t>LLM-Augmented Alert Triage for Security Operations Centers</a:t>
+              <a:t>Assisted Triage Alert for Security Operations Centers</a:t>
             </a:r>
             <a:endParaRPr lang="en-US" sz="1700" dirty="0"/>
           </a:p>
@@ -1466,7 +1437,7 @@
           <a:bodyPr wrap="square" lIns="0" tIns="0" rIns="0" bIns="0" rtlCol="0" anchor="ctr"/>
           <a:lstStyle/>
           <a:p>
-            <a:pPr algn="ctr" indent="0" marL="0">
+            <a:pPr marL="0" indent="0" algn="ctr">
               <a:buNone/>
             </a:pPr>
             <a:r>
@@ -1505,7 +1476,7 @@
           <a:bodyPr wrap="square" lIns="0" tIns="0" rIns="0" bIns="0" rtlCol="0" anchor="ctr"/>
           <a:lstStyle/>
           <a:p>
-            <a:pPr algn="ctr" indent="0" marL="0">
+            <a:pPr marL="0" indent="0" algn="ctr">
               <a:buNone/>
             </a:pPr>
             <a:r>
@@ -1533,12 +1504,13 @@
 
 <file path=ppt/slides/slide2.xml><?xml version="1.0" encoding="utf-8"?>
 <p:sld xmlns:a="http://schemas.openxmlformats.org/drawingml/2006/main" xmlns:r="http://schemas.openxmlformats.org/officeDocument/2006/relationships" xmlns:p="http://schemas.openxmlformats.org/presentationml/2006/main">
-  <p:cSld name="Slide 2">
+  <p:cSld name="Slide 1">
     <p:bg>
       <p:bgPr>
         <a:solidFill>
           <a:srgbClr val="0F1923"/>
         </a:solidFill>
+        <a:effectLst/>
       </p:bgPr>
     </p:bg>
     <p:spTree>
@@ -1574,6 +1546,13 @@
           </a:solidFill>
           <a:ln/>
         </p:spPr>
+        <p:txBody>
+          <a:bodyPr/>
+          <a:lstStyle/>
+          <a:p>
+            <a:endParaRPr lang="en-US"/>
+          </a:p>
+        </p:txBody>
       </p:sp>
       <p:sp>
         <p:nvSpPr>
@@ -1596,7 +1575,7 @@
           <a:bodyPr wrap="square" lIns="0" tIns="0" rIns="0" bIns="0" rtlCol="0" anchor="ctr"/>
           <a:lstStyle/>
           <a:p>
-            <a:pPr algn="ctr" indent="0" marL="0">
+            <a:pPr marL="0" indent="0" algn="ctr">
               <a:buNone/>
             </a:pPr>
             <a:r>
@@ -1635,7 +1614,7 @@
           <a:bodyPr wrap="square" lIns="0" tIns="0" rIns="0" bIns="0" rtlCol="0" anchor="ctr"/>
           <a:lstStyle/>
           <a:p>
-            <a:pPr indent="0" marL="0">
+            <a:pPr marL="0" indent="0">
               <a:buNone/>
             </a:pPr>
             <a:r>
@@ -1647,7 +1626,7 @@
                 <a:ea typeface="Calibri" pitchFamily="34" charset="-122"/>
                 <a:cs typeface="Calibri" pitchFamily="34" charset="-120"/>
               </a:rPr>
-              <a:t>Context, User &amp; Problem</a:t>
+              <a:t>Context Problem</a:t>
             </a:r>
             <a:endParaRPr lang="en-US" sz="3000" dirty="0"/>
           </a:p>
@@ -1674,7 +1653,7 @@
           <a:bodyPr wrap="square" lIns="0" tIns="0" rIns="0" bIns="0" rtlCol="0" anchor="ctr"/>
           <a:lstStyle/>
           <a:p>
-            <a:pPr indent="0" marL="0">
+            <a:pPr marL="0" indent="0">
               <a:buNone/>
             </a:pPr>
             <a:r>
@@ -1713,7 +1692,7 @@
           <a:bodyPr wrap="square" lIns="0" tIns="0" rIns="0" bIns="0" rtlCol="0" anchor="t"/>
           <a:lstStyle/>
           <a:p>
-            <a:pPr indent="0" marL="0">
+            <a:pPr marL="0" indent="0">
               <a:buNone/>
             </a:pPr>
             <a:r>
@@ -1752,7 +1731,7 @@
           <a:bodyPr wrap="square" lIns="0" tIns="0" rIns="0" bIns="0" rtlCol="0" anchor="ctr"/>
           <a:lstStyle/>
           <a:p>
-            <a:pPr indent="0" marL="0">
+            <a:pPr marL="0" indent="0">
               <a:buNone/>
             </a:pPr>
             <a:r>
@@ -1791,7 +1770,7 @@
           <a:bodyPr wrap="square" lIns="0" tIns="0" rIns="0" bIns="0" rtlCol="0" anchor="t"/>
           <a:lstStyle/>
           <a:p>
-            <a:pPr indent="0" marL="0">
+            <a:pPr marL="0" indent="0">
               <a:buNone/>
             </a:pPr>
             <a:r>
@@ -1830,7 +1809,7 @@
           <a:bodyPr wrap="square" lIns="0" tIns="0" rIns="0" bIns="0" rtlCol="0" anchor="ctr"/>
           <a:lstStyle/>
           <a:p>
-            <a:pPr indent="0" marL="0">
+            <a:pPr marL="0" indent="0">
               <a:buNone/>
             </a:pPr>
             <a:r>
@@ -1869,7 +1848,7 @@
           <a:bodyPr wrap="square" lIns="0" tIns="0" rIns="0" bIns="0" rtlCol="0" anchor="t"/>
           <a:lstStyle/>
           <a:p>
-            <a:pPr indent="0" marL="0">
+            <a:pPr marL="0" indent="0">
               <a:buNone/>
             </a:pPr>
             <a:r>
@@ -1906,13 +1885,20 @@
           </a:solidFill>
           <a:ln/>
           <a:effectLst>
-            <a:outerShdw sx="100000" sy="100000" kx="0" ky="0" algn="bl" rotWithShape="0" blurRad="127000" dist="50800" dir="8100000">
+            <a:outerShdw blurRad="127000" dist="50800" dir="8100000" algn="bl" rotWithShape="0">
               <a:srgbClr val="000000">
                 <a:alpha val="28000"/>
               </a:srgbClr>
             </a:outerShdw>
           </a:effectLst>
         </p:spPr>
+        <p:txBody>
+          <a:bodyPr/>
+          <a:lstStyle/>
+          <a:p>
+            <a:endParaRPr lang="en-US"/>
+          </a:p>
+        </p:txBody>
       </p:sp>
       <p:sp>
         <p:nvSpPr>
@@ -1933,6 +1919,13 @@
           </a:solidFill>
           <a:ln/>
         </p:spPr>
+        <p:txBody>
+          <a:bodyPr/>
+          <a:lstStyle/>
+          <a:p>
+            <a:endParaRPr lang="en-US"/>
+          </a:p>
+        </p:txBody>
       </p:sp>
       <p:sp>
         <p:nvSpPr>
@@ -1955,7 +1948,7 @@
           <a:bodyPr wrap="square" lIns="0" tIns="0" rIns="0" bIns="0" rtlCol="0" anchor="ctr"/>
           <a:lstStyle/>
           <a:p>
-            <a:pPr indent="0" marL="0">
+            <a:pPr marL="0" indent="0">
               <a:buNone/>
             </a:pPr>
             <a:r>
@@ -1994,7 +1987,7 @@
           <a:bodyPr wrap="square" lIns="0" tIns="0" rIns="0" bIns="0" rtlCol="0" anchor="t"/>
           <a:lstStyle/>
           <a:p>
-            <a:pPr indent="0" marL="0">
+            <a:pPr marL="0" indent="0">
               <a:buNone/>
             </a:pPr>
             <a:r>
@@ -2031,13 +2024,20 @@
           </a:solidFill>
           <a:ln/>
           <a:effectLst>
-            <a:outerShdw sx="100000" sy="100000" kx="0" ky="0" algn="bl" rotWithShape="0" blurRad="127000" dist="50800" dir="8100000">
+            <a:outerShdw blurRad="127000" dist="50800" dir="8100000" algn="bl" rotWithShape="0">
               <a:srgbClr val="000000">
                 <a:alpha val="28000"/>
               </a:srgbClr>
             </a:outerShdw>
           </a:effectLst>
         </p:spPr>
+        <p:txBody>
+          <a:bodyPr/>
+          <a:lstStyle/>
+          <a:p>
+            <a:endParaRPr lang="en-US"/>
+          </a:p>
+        </p:txBody>
       </p:sp>
       <p:sp>
         <p:nvSpPr>
@@ -2058,6 +2058,13 @@
           </a:solidFill>
           <a:ln/>
         </p:spPr>
+        <p:txBody>
+          <a:bodyPr/>
+          <a:lstStyle/>
+          <a:p>
+            <a:endParaRPr lang="en-US"/>
+          </a:p>
+        </p:txBody>
       </p:sp>
       <p:sp>
         <p:nvSpPr>
@@ -2080,7 +2087,7 @@
           <a:bodyPr wrap="square" lIns="0" tIns="0" rIns="0" bIns="0" rtlCol="0" anchor="ctr"/>
           <a:lstStyle/>
           <a:p>
-            <a:pPr indent="0" marL="0">
+            <a:pPr marL="0" indent="0">
               <a:buNone/>
             </a:pPr>
             <a:r>
@@ -2119,7 +2126,7 @@
           <a:bodyPr wrap="square" lIns="0" tIns="0" rIns="0" bIns="0" rtlCol="0" anchor="t"/>
           <a:lstStyle/>
           <a:p>
-            <a:pPr indent="0" marL="0">
+            <a:pPr marL="0" indent="0">
               <a:buNone/>
             </a:pPr>
             <a:r>
@@ -2156,13 +2163,20 @@
           </a:solidFill>
           <a:ln/>
           <a:effectLst>
-            <a:outerShdw sx="100000" sy="100000" kx="0" ky="0" algn="bl" rotWithShape="0" blurRad="127000" dist="50800" dir="8100000">
+            <a:outerShdw blurRad="127000" dist="50800" dir="8100000" algn="bl" rotWithShape="0">
               <a:srgbClr val="000000">
                 <a:alpha val="28000"/>
               </a:srgbClr>
             </a:outerShdw>
           </a:effectLst>
         </p:spPr>
+        <p:txBody>
+          <a:bodyPr/>
+          <a:lstStyle/>
+          <a:p>
+            <a:endParaRPr lang="en-US"/>
+          </a:p>
+        </p:txBody>
       </p:sp>
       <p:sp>
         <p:nvSpPr>
@@ -2183,6 +2197,13 @@
           </a:solidFill>
           <a:ln/>
         </p:spPr>
+        <p:txBody>
+          <a:bodyPr/>
+          <a:lstStyle/>
+          <a:p>
+            <a:endParaRPr lang="en-US"/>
+          </a:p>
+        </p:txBody>
       </p:sp>
       <p:sp>
         <p:nvSpPr>
@@ -2205,7 +2226,7 @@
           <a:bodyPr wrap="square" lIns="0" tIns="0" rIns="0" bIns="0" rtlCol="0" anchor="ctr"/>
           <a:lstStyle/>
           <a:p>
-            <a:pPr indent="0" marL="0">
+            <a:pPr marL="0" indent="0">
               <a:buNone/>
             </a:pPr>
             <a:r>
@@ -2244,7 +2265,7 @@
           <a:bodyPr wrap="square" lIns="0" tIns="0" rIns="0" bIns="0" rtlCol="0" anchor="t"/>
           <a:lstStyle/>
           <a:p>
-            <a:pPr indent="0" marL="0">
+            <a:pPr marL="0" indent="0">
               <a:buNone/>
             </a:pPr>
             <a:r>
@@ -2272,12 +2293,13 @@
 
 <file path=ppt/slides/slide3.xml><?xml version="1.0" encoding="utf-8"?>
 <p:sld xmlns:a="http://schemas.openxmlformats.org/drawingml/2006/main" xmlns:r="http://schemas.openxmlformats.org/officeDocument/2006/relationships" xmlns:p="http://schemas.openxmlformats.org/presentationml/2006/main">
-  <p:cSld name="Slide 3">
+  <p:cSld name="Slide 2">
     <p:bg>
       <p:bgPr>
         <a:solidFill>
           <a:srgbClr val="0F1923"/>
         </a:solidFill>
+        <a:effectLst/>
       </p:bgPr>
     </p:bg>
     <p:spTree>
@@ -2313,6 +2335,13 @@
           </a:solidFill>
           <a:ln/>
         </p:spPr>
+        <p:txBody>
+          <a:bodyPr/>
+          <a:lstStyle/>
+          <a:p>
+            <a:endParaRPr lang="en-US"/>
+          </a:p>
+        </p:txBody>
       </p:sp>
       <p:sp>
         <p:nvSpPr>
@@ -2335,7 +2364,7 @@
           <a:bodyPr wrap="square" lIns="0" tIns="0" rIns="0" bIns="0" rtlCol="0" anchor="ctr"/>
           <a:lstStyle/>
           <a:p>
-            <a:pPr algn="ctr" indent="0" marL="0">
+            <a:pPr marL="0" indent="0" algn="ctr">
               <a:buNone/>
             </a:pPr>
             <a:r>
@@ -2374,7 +2403,7 @@
           <a:bodyPr wrap="square" lIns="0" tIns="0" rIns="0" bIns="0" rtlCol="0" anchor="ctr"/>
           <a:lstStyle/>
           <a:p>
-            <a:pPr indent="0" marL="0">
+            <a:pPr marL="0" indent="0">
               <a:buNone/>
             </a:pPr>
             <a:r>
@@ -2413,7 +2442,7 @@
           <a:bodyPr wrap="square" lIns="0" tIns="0" rIns="0" bIns="0" rtlCol="0" anchor="ctr"/>
           <a:lstStyle/>
           <a:p>
-            <a:pPr indent="0" marL="0">
+            <a:pPr marL="0" indent="0">
               <a:buNone/>
             </a:pPr>
             <a:r>
@@ -2450,13 +2479,20 @@
           </a:solidFill>
           <a:ln/>
           <a:effectLst>
-            <a:outerShdw sx="100000" sy="100000" kx="0" ky="0" algn="bl" rotWithShape="0" blurRad="127000" dist="50800" dir="8100000">
+            <a:outerShdw blurRad="127000" dist="50800" dir="8100000" algn="bl" rotWithShape="0">
               <a:srgbClr val="000000">
                 <a:alpha val="28000"/>
               </a:srgbClr>
             </a:outerShdw>
           </a:effectLst>
         </p:spPr>
+        <p:txBody>
+          <a:bodyPr/>
+          <a:lstStyle/>
+          <a:p>
+            <a:endParaRPr lang="en-US"/>
+          </a:p>
+        </p:txBody>
       </p:sp>
       <p:sp>
         <p:nvSpPr>
@@ -2477,6 +2513,13 @@
           </a:solidFill>
           <a:ln/>
         </p:spPr>
+        <p:txBody>
+          <a:bodyPr/>
+          <a:lstStyle/>
+          <a:p>
+            <a:endParaRPr lang="en-US"/>
+          </a:p>
+        </p:txBody>
       </p:sp>
       <p:sp>
         <p:nvSpPr>
@@ -2499,7 +2542,7 @@
           <a:bodyPr wrap="square" lIns="0" tIns="0" rIns="0" bIns="0" rtlCol="0" anchor="ctr"/>
           <a:lstStyle/>
           <a:p>
-            <a:pPr indent="0" marL="0">
+            <a:pPr marL="0" indent="0">
               <a:buNone/>
             </a:pPr>
             <a:r>
@@ -2538,7 +2581,7 @@
           <a:bodyPr wrap="square" lIns="0" tIns="0" rIns="0" bIns="0" rtlCol="0" anchor="ctr"/>
           <a:lstStyle/>
           <a:p>
-            <a:pPr indent="0" marL="0">
+            <a:pPr marL="0" indent="0">
               <a:buNone/>
             </a:pPr>
             <a:r>
@@ -2577,7 +2620,7 @@
           <a:bodyPr wrap="square" lIns="0" tIns="0" rIns="0" bIns="0" rtlCol="0" anchor="t"/>
           <a:lstStyle/>
           <a:p>
-            <a:pPr indent="0" marL="0">
+            <a:pPr marL="0" indent="0">
               <a:buNone/>
             </a:pPr>
             <a:r>
@@ -2614,13 +2657,20 @@
           </a:solidFill>
           <a:ln/>
           <a:effectLst>
-            <a:outerShdw sx="100000" sy="100000" kx="0" ky="0" algn="bl" rotWithShape="0" blurRad="127000" dist="50800" dir="8100000">
+            <a:outerShdw blurRad="127000" dist="50800" dir="8100000" algn="bl" rotWithShape="0">
               <a:srgbClr val="000000">
                 <a:alpha val="28000"/>
               </a:srgbClr>
             </a:outerShdw>
           </a:effectLst>
         </p:spPr>
+        <p:txBody>
+          <a:bodyPr/>
+          <a:lstStyle/>
+          <a:p>
+            <a:endParaRPr lang="en-US"/>
+          </a:p>
+        </p:txBody>
       </p:sp>
       <p:sp>
         <p:nvSpPr>
@@ -2641,6 +2691,13 @@
           </a:solidFill>
           <a:ln/>
         </p:spPr>
+        <p:txBody>
+          <a:bodyPr/>
+          <a:lstStyle/>
+          <a:p>
+            <a:endParaRPr lang="en-US"/>
+          </a:p>
+        </p:txBody>
       </p:sp>
       <p:sp>
         <p:nvSpPr>
@@ -2663,7 +2720,7 @@
           <a:bodyPr wrap="square" lIns="0" tIns="0" rIns="0" bIns="0" rtlCol="0" anchor="ctr"/>
           <a:lstStyle/>
           <a:p>
-            <a:pPr indent="0" marL="0">
+            <a:pPr marL="0" indent="0">
               <a:buNone/>
             </a:pPr>
             <a:r>
@@ -2702,7 +2759,7 @@
           <a:bodyPr wrap="square" lIns="0" tIns="0" rIns="0" bIns="0" rtlCol="0" anchor="ctr"/>
           <a:lstStyle/>
           <a:p>
-            <a:pPr indent="0" marL="0">
+            <a:pPr marL="0" indent="0">
               <a:buNone/>
             </a:pPr>
             <a:r>
@@ -2741,7 +2798,7 @@
           <a:bodyPr wrap="square" lIns="0" tIns="0" rIns="0" bIns="0" rtlCol="0" anchor="t"/>
           <a:lstStyle/>
           <a:p>
-            <a:pPr indent="0" marL="0">
+            <a:pPr marL="0" indent="0">
               <a:buNone/>
             </a:pPr>
             <a:r>
@@ -2778,13 +2835,20 @@
           </a:solidFill>
           <a:ln/>
           <a:effectLst>
-            <a:outerShdw sx="100000" sy="100000" kx="0" ky="0" algn="bl" rotWithShape="0" blurRad="127000" dist="50800" dir="8100000">
+            <a:outerShdw blurRad="127000" dist="50800" dir="8100000" algn="bl" rotWithShape="0">
               <a:srgbClr val="000000">
                 <a:alpha val="28000"/>
               </a:srgbClr>
             </a:outerShdw>
           </a:effectLst>
         </p:spPr>
+        <p:txBody>
+          <a:bodyPr/>
+          <a:lstStyle/>
+          <a:p>
+            <a:endParaRPr lang="en-US"/>
+          </a:p>
+        </p:txBody>
       </p:sp>
       <p:sp>
         <p:nvSpPr>
@@ -2805,6 +2869,13 @@
           </a:solidFill>
           <a:ln/>
         </p:spPr>
+        <p:txBody>
+          <a:bodyPr/>
+          <a:lstStyle/>
+          <a:p>
+            <a:endParaRPr lang="en-US"/>
+          </a:p>
+        </p:txBody>
       </p:sp>
       <p:sp>
         <p:nvSpPr>
@@ -2827,7 +2898,7 @@
           <a:bodyPr wrap="square" lIns="0" tIns="0" rIns="0" bIns="0" rtlCol="0" anchor="ctr"/>
           <a:lstStyle/>
           <a:p>
-            <a:pPr indent="0" marL="0">
+            <a:pPr marL="0" indent="0">
               <a:buNone/>
             </a:pPr>
             <a:r>
@@ -2866,7 +2937,7 @@
           <a:bodyPr wrap="square" lIns="0" tIns="0" rIns="0" bIns="0" rtlCol="0" anchor="ctr"/>
           <a:lstStyle/>
           <a:p>
-            <a:pPr indent="0" marL="0">
+            <a:pPr marL="0" indent="0">
               <a:buNone/>
             </a:pPr>
             <a:r>
@@ -2905,7 +2976,7 @@
           <a:bodyPr wrap="square" lIns="0" tIns="0" rIns="0" bIns="0" rtlCol="0" anchor="t"/>
           <a:lstStyle/>
           <a:p>
-            <a:pPr indent="0" marL="0">
+            <a:pPr marL="0" indent="0">
               <a:buNone/>
             </a:pPr>
             <a:r>
@@ -2944,7 +3015,7 @@
           <a:bodyPr wrap="square" lIns="0" tIns="0" rIns="0" bIns="0" rtlCol="0" anchor="ctr"/>
           <a:lstStyle/>
           <a:p>
-            <a:pPr indent="0" marL="0">
+            <a:pPr marL="0" indent="0">
               <a:buNone/>
             </a:pPr>
             <a:r>
@@ -2981,13 +3052,20 @@
           </a:solidFill>
           <a:ln/>
           <a:effectLst>
-            <a:outerShdw sx="100000" sy="100000" kx="0" ky="0" algn="bl" rotWithShape="0" blurRad="127000" dist="50800" dir="8100000">
+            <a:outerShdw blurRad="127000" dist="50800" dir="8100000" algn="bl" rotWithShape="0">
               <a:srgbClr val="000000">
                 <a:alpha val="28000"/>
               </a:srgbClr>
             </a:outerShdw>
           </a:effectLst>
         </p:spPr>
+        <p:txBody>
+          <a:bodyPr/>
+          <a:lstStyle/>
+          <a:p>
+            <a:endParaRPr lang="en-US"/>
+          </a:p>
+        </p:txBody>
       </p:sp>
       <p:sp>
         <p:nvSpPr>
@@ -3010,7 +3088,7 @@
           <a:bodyPr wrap="square" lIns="0" tIns="0" rIns="0" bIns="0" rtlCol="0" anchor="ctr"/>
           <a:lstStyle/>
           <a:p>
-            <a:pPr indent="0" marL="0">
+            <a:pPr marL="0" indent="0">
               <a:buNone/>
             </a:pPr>
             <a:r>
@@ -3049,7 +3127,7 @@
           <a:bodyPr wrap="square" lIns="0" tIns="0" rIns="0" bIns="0" rtlCol="0" anchor="t"/>
           <a:lstStyle/>
           <a:p>
-            <a:pPr indent="0" marL="0">
+            <a:pPr marL="0" indent="0">
               <a:buNone/>
             </a:pPr>
             <a:r>
@@ -3086,13 +3164,20 @@
           </a:solidFill>
           <a:ln/>
           <a:effectLst>
-            <a:outerShdw sx="100000" sy="100000" kx="0" ky="0" algn="bl" rotWithShape="0" blurRad="127000" dist="50800" dir="8100000">
+            <a:outerShdw blurRad="127000" dist="50800" dir="8100000" algn="bl" rotWithShape="0">
               <a:srgbClr val="000000">
                 <a:alpha val="28000"/>
               </a:srgbClr>
             </a:outerShdw>
           </a:effectLst>
         </p:spPr>
+        <p:txBody>
+          <a:bodyPr/>
+          <a:lstStyle/>
+          <a:p>
+            <a:endParaRPr lang="en-US"/>
+          </a:p>
+        </p:txBody>
       </p:sp>
       <p:sp>
         <p:nvSpPr>
@@ -3115,7 +3200,7 @@
           <a:bodyPr wrap="square" lIns="0" tIns="0" rIns="0" bIns="0" rtlCol="0" anchor="ctr"/>
           <a:lstStyle/>
           <a:p>
-            <a:pPr indent="0" marL="0">
+            <a:pPr marL="0" indent="0">
               <a:buNone/>
             </a:pPr>
             <a:r>
@@ -3154,7 +3239,7 @@
           <a:bodyPr wrap="square" lIns="0" tIns="0" rIns="0" bIns="0" rtlCol="0" anchor="t"/>
           <a:lstStyle/>
           <a:p>
-            <a:pPr indent="0" marL="0">
+            <a:pPr marL="0" indent="0">
               <a:buNone/>
             </a:pPr>
             <a:r>
@@ -3191,13 +3276,20 @@
           </a:solidFill>
           <a:ln/>
           <a:effectLst>
-            <a:outerShdw sx="100000" sy="100000" kx="0" ky="0" algn="bl" rotWithShape="0" blurRad="127000" dist="50800" dir="8100000">
+            <a:outerShdw blurRad="127000" dist="50800" dir="8100000" algn="bl" rotWithShape="0">
               <a:srgbClr val="000000">
                 <a:alpha val="28000"/>
               </a:srgbClr>
             </a:outerShdw>
           </a:effectLst>
         </p:spPr>
+        <p:txBody>
+          <a:bodyPr/>
+          <a:lstStyle/>
+          <a:p>
+            <a:endParaRPr lang="en-US"/>
+          </a:p>
+        </p:txBody>
       </p:sp>
       <p:sp>
         <p:nvSpPr>
@@ -3220,7 +3312,7 @@
           <a:bodyPr wrap="square" lIns="0" tIns="0" rIns="0" bIns="0" rtlCol="0" anchor="ctr"/>
           <a:lstStyle/>
           <a:p>
-            <a:pPr indent="0" marL="0">
+            <a:pPr marL="0" indent="0">
               <a:buNone/>
             </a:pPr>
             <a:r>
@@ -3259,7 +3351,7 @@
           <a:bodyPr wrap="square" lIns="0" tIns="0" rIns="0" bIns="0" rtlCol="0" anchor="t"/>
           <a:lstStyle/>
           <a:p>
-            <a:pPr indent="0" marL="0">
+            <a:pPr marL="0" indent="0">
               <a:buNone/>
             </a:pPr>
             <a:r>
@@ -3296,13 +3388,20 @@
           </a:solidFill>
           <a:ln/>
           <a:effectLst>
-            <a:outerShdw sx="100000" sy="100000" kx="0" ky="0" algn="bl" rotWithShape="0" blurRad="127000" dist="50800" dir="8100000">
+            <a:outerShdw blurRad="127000" dist="50800" dir="8100000" algn="bl" rotWithShape="0">
               <a:srgbClr val="000000">
                 <a:alpha val="28000"/>
               </a:srgbClr>
             </a:outerShdw>
           </a:effectLst>
         </p:spPr>
+        <p:txBody>
+          <a:bodyPr/>
+          <a:lstStyle/>
+          <a:p>
+            <a:endParaRPr lang="en-US"/>
+          </a:p>
+        </p:txBody>
       </p:sp>
       <p:sp>
         <p:nvSpPr>
@@ -3325,7 +3424,7 @@
           <a:bodyPr wrap="square" lIns="0" tIns="0" rIns="0" bIns="0" rtlCol="0" anchor="ctr"/>
           <a:lstStyle/>
           <a:p>
-            <a:pPr indent="0" marL="0">
+            <a:pPr marL="0" indent="0">
               <a:buNone/>
             </a:pPr>
             <a:r>
@@ -3364,7 +3463,7 @@
           <a:bodyPr wrap="square" lIns="0" tIns="0" rIns="0" bIns="0" rtlCol="0" anchor="t"/>
           <a:lstStyle/>
           <a:p>
-            <a:pPr indent="0" marL="0">
+            <a:pPr marL="0" indent="0">
               <a:buNone/>
             </a:pPr>
             <a:r>
@@ -3392,12 +3491,13 @@
 
 <file path=ppt/slides/slide4.xml><?xml version="1.0" encoding="utf-8"?>
 <p:sld xmlns:a="http://schemas.openxmlformats.org/drawingml/2006/main" xmlns:r="http://schemas.openxmlformats.org/officeDocument/2006/relationships" xmlns:p="http://schemas.openxmlformats.org/presentationml/2006/main">
-  <p:cSld name="Slide 4">
+  <p:cSld name="Slide 3">
     <p:bg>
       <p:bgPr>
         <a:solidFill>
           <a:srgbClr val="0F1923"/>
         </a:solidFill>
+        <a:effectLst/>
       </p:bgPr>
     </p:bg>
     <p:spTree>
@@ -3433,6 +3533,13 @@
           </a:solidFill>
           <a:ln/>
         </p:spPr>
+        <p:txBody>
+          <a:bodyPr/>
+          <a:lstStyle/>
+          <a:p>
+            <a:endParaRPr lang="en-US"/>
+          </a:p>
+        </p:txBody>
       </p:sp>
       <p:sp>
         <p:nvSpPr>
@@ -3455,7 +3562,7 @@
           <a:bodyPr wrap="square" lIns="0" tIns="0" rIns="0" bIns="0" rtlCol="0" anchor="ctr"/>
           <a:lstStyle/>
           <a:p>
-            <a:pPr algn="ctr" indent="0" marL="0">
+            <a:pPr marL="0" indent="0" algn="ctr">
               <a:buNone/>
             </a:pPr>
             <a:r>
@@ -3494,7 +3601,7 @@
           <a:bodyPr wrap="square" lIns="0" tIns="0" rIns="0" bIns="0" rtlCol="0" anchor="ctr"/>
           <a:lstStyle/>
           <a:p>
-            <a:pPr indent="0" marL="0">
+            <a:pPr marL="0" indent="0">
               <a:buNone/>
             </a:pPr>
             <a:r>
@@ -3533,7 +3640,7 @@
           <a:bodyPr wrap="square" lIns="0" tIns="0" rIns="0" bIns="0" rtlCol="0" anchor="ctr"/>
           <a:lstStyle/>
           <a:p>
-            <a:pPr indent="0" marL="0">
+            <a:pPr marL="0" indent="0">
               <a:buNone/>
             </a:pPr>
             <a:r>
@@ -3570,13 +3677,20 @@
           </a:solidFill>
           <a:ln/>
           <a:effectLst>
-            <a:outerShdw sx="100000" sy="100000" kx="0" ky="0" algn="bl" rotWithShape="0" blurRad="127000" dist="50800" dir="8100000">
+            <a:outerShdw blurRad="127000" dist="50800" dir="8100000" algn="bl" rotWithShape="0">
               <a:srgbClr val="000000">
                 <a:alpha val="28000"/>
               </a:srgbClr>
             </a:outerShdw>
           </a:effectLst>
         </p:spPr>
+        <p:txBody>
+          <a:bodyPr/>
+          <a:lstStyle/>
+          <a:p>
+            <a:endParaRPr lang="en-US"/>
+          </a:p>
+        </p:txBody>
       </p:sp>
       <p:sp>
         <p:nvSpPr>
@@ -3599,7 +3713,7 @@
           <a:bodyPr wrap="square" lIns="0" tIns="0" rIns="0" bIns="0" rtlCol="0" anchor="ctr"/>
           <a:lstStyle/>
           <a:p>
-            <a:pPr algn="ctr" indent="0" marL="0">
+            <a:pPr marL="0" indent="0" algn="ctr">
               <a:buNone/>
             </a:pPr>
             <a:r>
@@ -3638,7 +3752,7 @@
           <a:bodyPr wrap="square" lIns="0" tIns="0" rIns="0" bIns="0" rtlCol="0" anchor="ctr"/>
           <a:lstStyle/>
           <a:p>
-            <a:pPr algn="ctr" indent="0" marL="0">
+            <a:pPr marL="0" indent="0" algn="ctr">
               <a:buNone/>
             </a:pPr>
             <a:r>
@@ -3677,7 +3791,7 @@
           <a:bodyPr wrap="square" lIns="0" tIns="0" rIns="0" bIns="0" rtlCol="0" anchor="ctr"/>
           <a:lstStyle/>
           <a:p>
-            <a:pPr algn="ctr" indent="0" marL="0">
+            <a:pPr marL="0" indent="0" algn="ctr">
               <a:buNone/>
             </a:pPr>
             <a:r>
@@ -3714,13 +3828,20 @@
           </a:solidFill>
           <a:ln/>
           <a:effectLst>
-            <a:outerShdw sx="100000" sy="100000" kx="0" ky="0" algn="bl" rotWithShape="0" blurRad="127000" dist="50800" dir="8100000">
+            <a:outerShdw blurRad="127000" dist="50800" dir="8100000" algn="bl" rotWithShape="0">
               <a:srgbClr val="000000">
                 <a:alpha val="28000"/>
               </a:srgbClr>
             </a:outerShdw>
           </a:effectLst>
         </p:spPr>
+        <p:txBody>
+          <a:bodyPr/>
+          <a:lstStyle/>
+          <a:p>
+            <a:endParaRPr lang="en-US"/>
+          </a:p>
+        </p:txBody>
       </p:sp>
       <p:sp>
         <p:nvSpPr>
@@ -3743,7 +3864,7 @@
           <a:bodyPr wrap="square" lIns="0" tIns="0" rIns="0" bIns="0" rtlCol="0" anchor="ctr"/>
           <a:lstStyle/>
           <a:p>
-            <a:pPr algn="ctr" indent="0" marL="0">
+            <a:pPr marL="0" indent="0" algn="ctr">
               <a:buNone/>
             </a:pPr>
             <a:r>
@@ -3752,10 +3873,9 @@
                   <a:srgbClr val="00B4D8"/>
                 </a:solidFill>
                 <a:latin typeface="Calibri" pitchFamily="34" charset="0"/>
-                <a:ea typeface="Calibri" pitchFamily="34" charset="-122"/>
-                <a:cs typeface="Calibri" pitchFamily="34" charset="-120"/>
-              </a:rPr>
-              <a:t>2</a:t>
+                <a:cs typeface="Calibri" pitchFamily="34" charset="-120"/>
+              </a:rPr>
+              <a:t>15</a:t>
             </a:r>
             <a:endParaRPr lang="en-US" sz="4000" dirty="0"/>
           </a:p>
@@ -3782,7 +3902,7 @@
           <a:bodyPr wrap="square" lIns="0" tIns="0" rIns="0" bIns="0" rtlCol="0" anchor="ctr"/>
           <a:lstStyle/>
           <a:p>
-            <a:pPr algn="ctr" indent="0" marL="0">
+            <a:pPr marL="0" indent="0" algn="ctr">
               <a:buNone/>
             </a:pPr>
             <a:r>
@@ -3821,7 +3941,7 @@
           <a:bodyPr wrap="square" lIns="0" tIns="0" rIns="0" bIns="0" rtlCol="0" anchor="ctr"/>
           <a:lstStyle/>
           <a:p>
-            <a:pPr algn="ctr" indent="0" marL="0">
+            <a:pPr marL="0" indent="0" algn="ctr">
               <a:buNone/>
             </a:pPr>
             <a:r>
@@ -3858,13 +3978,20 @@
           </a:solidFill>
           <a:ln/>
           <a:effectLst>
-            <a:outerShdw sx="100000" sy="100000" kx="0" ky="0" algn="bl" rotWithShape="0" blurRad="127000" dist="50800" dir="8100000">
+            <a:outerShdw blurRad="127000" dist="50800" dir="8100000" algn="bl" rotWithShape="0">
               <a:srgbClr val="000000">
                 <a:alpha val="28000"/>
               </a:srgbClr>
             </a:outerShdw>
           </a:effectLst>
         </p:spPr>
+        <p:txBody>
+          <a:bodyPr/>
+          <a:lstStyle/>
+          <a:p>
+            <a:endParaRPr lang="en-US"/>
+          </a:p>
+        </p:txBody>
       </p:sp>
       <p:sp>
         <p:nvSpPr>
@@ -3887,7 +4014,7 @@
           <a:bodyPr wrap="square" lIns="0" tIns="0" rIns="0" bIns="0" rtlCol="0" anchor="ctr"/>
           <a:lstStyle/>
           <a:p>
-            <a:pPr algn="ctr" indent="0" marL="0">
+            <a:pPr marL="0" indent="0" algn="ctr">
               <a:buNone/>
             </a:pPr>
             <a:r>
@@ -3926,7 +4053,7 @@
           <a:bodyPr wrap="square" lIns="0" tIns="0" rIns="0" bIns="0" rtlCol="0" anchor="ctr"/>
           <a:lstStyle/>
           <a:p>
-            <a:pPr algn="ctr" indent="0" marL="0">
+            <a:pPr marL="0" indent="0" algn="ctr">
               <a:buNone/>
             </a:pPr>
             <a:r>
@@ -3965,7 +4092,7 @@
           <a:bodyPr wrap="square" lIns="0" tIns="0" rIns="0" bIns="0" rtlCol="0" anchor="ctr"/>
           <a:lstStyle/>
           <a:p>
-            <a:pPr algn="ctr" indent="0" marL="0">
+            <a:pPr marL="0" indent="0" algn="ctr">
               <a:buNone/>
             </a:pPr>
             <a:r>
@@ -4002,6 +4129,13 @@
           </a:solidFill>
           <a:ln/>
         </p:spPr>
+        <p:txBody>
+          <a:bodyPr/>
+          <a:lstStyle/>
+          <a:p>
+            <a:endParaRPr lang="en-US"/>
+          </a:p>
+        </p:txBody>
       </p:sp>
       <p:sp>
         <p:nvSpPr>
@@ -4024,7 +4158,7 @@
           <a:bodyPr wrap="square" lIns="0" tIns="0" rIns="0" bIns="0" rtlCol="0" anchor="ctr"/>
           <a:lstStyle/>
           <a:p>
-            <a:pPr algn="ctr" indent="0" marL="0">
+            <a:pPr marL="0" indent="0" algn="ctr">
               <a:buNone/>
             </a:pPr>
             <a:r>
@@ -4061,6 +4195,13 @@
           </a:solidFill>
           <a:ln/>
         </p:spPr>
+        <p:txBody>
+          <a:bodyPr/>
+          <a:lstStyle/>
+          <a:p>
+            <a:endParaRPr lang="en-US"/>
+          </a:p>
+        </p:txBody>
       </p:sp>
       <p:sp>
         <p:nvSpPr>
@@ -4083,7 +4224,7 @@
           <a:bodyPr wrap="square" lIns="0" tIns="0" rIns="0" bIns="0" rtlCol="0" anchor="ctr"/>
           <a:lstStyle/>
           <a:p>
-            <a:pPr indent="0" marL="0">
+            <a:pPr marL="0" indent="0">
               <a:buNone/>
             </a:pPr>
             <a:r>
@@ -4122,7 +4263,7 @@
           <a:bodyPr wrap="square" lIns="0" tIns="0" rIns="0" bIns="0" rtlCol="0" anchor="ctr"/>
           <a:lstStyle/>
           <a:p>
-            <a:pPr indent="0" marL="0">
+            <a:pPr marL="0" indent="0">
               <a:buNone/>
             </a:pPr>
             <a:r>
@@ -4159,6 +4300,13 @@
           </a:solidFill>
           <a:ln/>
         </p:spPr>
+        <p:txBody>
+          <a:bodyPr/>
+          <a:lstStyle/>
+          <a:p>
+            <a:endParaRPr lang="en-US"/>
+          </a:p>
+        </p:txBody>
       </p:sp>
       <p:sp>
         <p:nvSpPr>
@@ -4181,7 +4329,7 @@
           <a:bodyPr wrap="square" lIns="0" tIns="0" rIns="0" bIns="0" rtlCol="0" anchor="ctr"/>
           <a:lstStyle/>
           <a:p>
-            <a:pPr indent="0" marL="0">
+            <a:pPr marL="0" indent="0">
               <a:buNone/>
             </a:pPr>
             <a:r>
@@ -4220,7 +4368,7 @@
           <a:bodyPr wrap="square" lIns="0" tIns="0" rIns="0" bIns="0" rtlCol="0" anchor="ctr"/>
           <a:lstStyle/>
           <a:p>
-            <a:pPr indent="0" marL="0">
+            <a:pPr marL="0" indent="0">
               <a:buNone/>
             </a:pPr>
             <a:r>
@@ -4257,6 +4405,13 @@
           </a:solidFill>
           <a:ln/>
         </p:spPr>
+        <p:txBody>
+          <a:bodyPr/>
+          <a:lstStyle/>
+          <a:p>
+            <a:endParaRPr lang="en-US"/>
+          </a:p>
+        </p:txBody>
       </p:sp>
       <p:sp>
         <p:nvSpPr>
@@ -4279,7 +4434,7 @@
           <a:bodyPr wrap="square" lIns="0" tIns="0" rIns="0" bIns="0" rtlCol="0" anchor="ctr"/>
           <a:lstStyle/>
           <a:p>
-            <a:pPr indent="0" marL="0">
+            <a:pPr marL="0" indent="0">
               <a:buNone/>
             </a:pPr>
             <a:r>
@@ -4318,7 +4473,7 @@
           <a:bodyPr wrap="square" lIns="0" tIns="0" rIns="0" bIns="0" rtlCol="0" anchor="ctr"/>
           <a:lstStyle/>
           <a:p>
-            <a:pPr indent="0" marL="0">
+            <a:pPr marL="0" indent="0">
               <a:buNone/>
             </a:pPr>
             <a:r>
@@ -4355,6 +4510,13 @@
           </a:solidFill>
           <a:ln/>
         </p:spPr>
+        <p:txBody>
+          <a:bodyPr/>
+          <a:lstStyle/>
+          <a:p>
+            <a:endParaRPr lang="en-US"/>
+          </a:p>
+        </p:txBody>
       </p:sp>
       <p:sp>
         <p:nvSpPr>
@@ -4377,7 +4539,7 @@
           <a:bodyPr wrap="square" lIns="0" tIns="0" rIns="0" bIns="0" rtlCol="0" anchor="ctr"/>
           <a:lstStyle/>
           <a:p>
-            <a:pPr indent="0" marL="0">
+            <a:pPr marL="0" indent="0">
               <a:buNone/>
             </a:pPr>
             <a:r>
@@ -4416,7 +4578,7 @@
           <a:bodyPr wrap="square" lIns="0" tIns="0" rIns="0" bIns="0" rtlCol="0" anchor="ctr"/>
           <a:lstStyle/>
           <a:p>
-            <a:pPr indent="0" marL="0">
+            <a:pPr marL="0" indent="0">
               <a:buNone/>
             </a:pPr>
             <a:r>
@@ -4453,6 +4615,13 @@
           </a:solidFill>
           <a:ln/>
         </p:spPr>
+        <p:txBody>
+          <a:bodyPr/>
+          <a:lstStyle/>
+          <a:p>
+            <a:endParaRPr lang="en-US"/>
+          </a:p>
+        </p:txBody>
       </p:sp>
       <p:sp>
         <p:nvSpPr>
@@ -4475,7 +4644,7 @@
           <a:bodyPr wrap="square" lIns="0" tIns="0" rIns="0" bIns="0" rtlCol="0" anchor="ctr"/>
           <a:lstStyle/>
           <a:p>
-            <a:pPr indent="0" marL="0">
+            <a:pPr marL="0" indent="0">
               <a:buNone/>
             </a:pPr>
             <a:r>
@@ -4514,7 +4683,7 @@
           <a:bodyPr wrap="square" lIns="0" tIns="0" rIns="0" bIns="0" rtlCol="0" anchor="ctr"/>
           <a:lstStyle/>
           <a:p>
-            <a:pPr indent="0" marL="0">
+            <a:pPr marL="0" indent="0">
               <a:buNone/>
             </a:pPr>
             <a:r>
@@ -4551,6 +4720,13 @@
           </a:solidFill>
           <a:ln/>
         </p:spPr>
+        <p:txBody>
+          <a:bodyPr/>
+          <a:lstStyle/>
+          <a:p>
+            <a:endParaRPr lang="en-US"/>
+          </a:p>
+        </p:txBody>
       </p:sp>
       <p:sp>
         <p:nvSpPr>
@@ -4573,7 +4749,7 @@
           <a:bodyPr wrap="square" lIns="0" tIns="0" rIns="0" bIns="0" rtlCol="0" anchor="ctr"/>
           <a:lstStyle/>
           <a:p>
-            <a:pPr indent="0" marL="0">
+            <a:pPr marL="0" indent="0">
               <a:buNone/>
             </a:pPr>
             <a:r>
@@ -4612,7 +4788,7 @@
           <a:bodyPr wrap="square" lIns="0" tIns="0" rIns="0" bIns="0" rtlCol="0" anchor="ctr"/>
           <a:lstStyle/>
           <a:p>
-            <a:pPr indent="0" marL="0">
+            <a:pPr marL="0" indent="0">
               <a:buNone/>
             </a:pPr>
             <a:r>
@@ -4649,6 +4825,13 @@
           </a:solidFill>
           <a:ln/>
         </p:spPr>
+        <p:txBody>
+          <a:bodyPr/>
+          <a:lstStyle/>
+          <a:p>
+            <a:endParaRPr lang="en-US"/>
+          </a:p>
+        </p:txBody>
       </p:sp>
       <p:sp>
         <p:nvSpPr>
@@ -4671,7 +4854,7 @@
           <a:bodyPr wrap="square" lIns="0" tIns="0" rIns="0" bIns="0" rtlCol="0" anchor="ctr"/>
           <a:lstStyle/>
           <a:p>
-            <a:pPr algn="ctr" indent="0" marL="0">
+            <a:pPr marL="0" indent="0" algn="ctr">
               <a:buNone/>
             </a:pPr>
             <a:r>
@@ -4683,7 +4866,7 @@
                 <a:ea typeface="Calibri" pitchFamily="34" charset="-122"/>
                 <a:cs typeface="Calibri" pitchFamily="34" charset="-120"/>
               </a:rPr>
-              <a:t>TC3  ·  STRRAT  (2024-07-30,  post-fix)</a:t>
+              <a:t>TC2  ·  STRRAT  (2024-07-30,  post-fix)</a:t>
             </a:r>
             <a:endParaRPr lang="en-US" sz="950" dirty="0"/>
           </a:p>
@@ -4708,6 +4891,13 @@
           </a:solidFill>
           <a:ln/>
         </p:spPr>
+        <p:txBody>
+          <a:bodyPr/>
+          <a:lstStyle/>
+          <a:p>
+            <a:endParaRPr lang="en-US"/>
+          </a:p>
+        </p:txBody>
       </p:sp>
       <p:sp>
         <p:nvSpPr>
@@ -4730,7 +4920,7 @@
           <a:bodyPr wrap="square" lIns="0" tIns="0" rIns="0" bIns="0" rtlCol="0" anchor="ctr"/>
           <a:lstStyle/>
           <a:p>
-            <a:pPr indent="0" marL="0">
+            <a:pPr marL="0" indent="0">
               <a:buNone/>
             </a:pPr>
             <a:r>
@@ -4769,7 +4959,7 @@
           <a:bodyPr wrap="square" lIns="0" tIns="0" rIns="0" bIns="0" rtlCol="0" anchor="ctr"/>
           <a:lstStyle/>
           <a:p>
-            <a:pPr indent="0" marL="0">
+            <a:pPr marL="0" indent="0">
               <a:buNone/>
             </a:pPr>
             <a:r>
@@ -4806,6 +4996,13 @@
           </a:solidFill>
           <a:ln/>
         </p:spPr>
+        <p:txBody>
+          <a:bodyPr/>
+          <a:lstStyle/>
+          <a:p>
+            <a:endParaRPr lang="en-US"/>
+          </a:p>
+        </p:txBody>
       </p:sp>
       <p:sp>
         <p:nvSpPr>
@@ -4828,7 +5025,7 @@
           <a:bodyPr wrap="square" lIns="0" tIns="0" rIns="0" bIns="0" rtlCol="0" anchor="ctr"/>
           <a:lstStyle/>
           <a:p>
-            <a:pPr indent="0" marL="0">
+            <a:pPr marL="0" indent="0">
               <a:buNone/>
             </a:pPr>
             <a:r>
@@ -4867,7 +5064,7 @@
           <a:bodyPr wrap="square" lIns="0" tIns="0" rIns="0" bIns="0" rtlCol="0" anchor="ctr"/>
           <a:lstStyle/>
           <a:p>
-            <a:pPr indent="0" marL="0">
+            <a:pPr marL="0" indent="0">
               <a:buNone/>
             </a:pPr>
             <a:r>
@@ -4904,6 +5101,13 @@
           </a:solidFill>
           <a:ln/>
         </p:spPr>
+        <p:txBody>
+          <a:bodyPr/>
+          <a:lstStyle/>
+          <a:p>
+            <a:endParaRPr lang="en-US"/>
+          </a:p>
+        </p:txBody>
       </p:sp>
       <p:sp>
         <p:nvSpPr>
@@ -4926,7 +5130,7 @@
           <a:bodyPr wrap="square" lIns="0" tIns="0" rIns="0" bIns="0" rtlCol="0" anchor="ctr"/>
           <a:lstStyle/>
           <a:p>
-            <a:pPr indent="0" marL="0">
+            <a:pPr marL="0" indent="0">
               <a:buNone/>
             </a:pPr>
             <a:r>
@@ -4965,7 +5169,7 @@
           <a:bodyPr wrap="square" lIns="0" tIns="0" rIns="0" bIns="0" rtlCol="0" anchor="ctr"/>
           <a:lstStyle/>
           <a:p>
-            <a:pPr indent="0" marL="0">
+            <a:pPr marL="0" indent="0">
               <a:buNone/>
             </a:pPr>
             <a:r>
@@ -5002,6 +5206,13 @@
           </a:solidFill>
           <a:ln/>
         </p:spPr>
+        <p:txBody>
+          <a:bodyPr/>
+          <a:lstStyle/>
+          <a:p>
+            <a:endParaRPr lang="en-US"/>
+          </a:p>
+        </p:txBody>
       </p:sp>
       <p:sp>
         <p:nvSpPr>
@@ -5024,7 +5235,7 @@
           <a:bodyPr wrap="square" lIns="0" tIns="0" rIns="0" bIns="0" rtlCol="0" anchor="ctr"/>
           <a:lstStyle/>
           <a:p>
-            <a:pPr indent="0" marL="0">
+            <a:pPr marL="0" indent="0">
               <a:buNone/>
             </a:pPr>
             <a:r>
@@ -5063,7 +5274,7 @@
           <a:bodyPr wrap="square" lIns="0" tIns="0" rIns="0" bIns="0" rtlCol="0" anchor="ctr"/>
           <a:lstStyle/>
           <a:p>
-            <a:pPr indent="0" marL="0">
+            <a:pPr marL="0" indent="0">
               <a:buNone/>
             </a:pPr>
             <a:r>
@@ -5100,6 +5311,13 @@
           </a:solidFill>
           <a:ln/>
         </p:spPr>
+        <p:txBody>
+          <a:bodyPr/>
+          <a:lstStyle/>
+          <a:p>
+            <a:endParaRPr lang="en-US"/>
+          </a:p>
+        </p:txBody>
       </p:sp>
       <p:sp>
         <p:nvSpPr>
@@ -5122,7 +5340,7 @@
           <a:bodyPr wrap="square" lIns="0" tIns="0" rIns="0" bIns="0" rtlCol="0" anchor="ctr"/>
           <a:lstStyle/>
           <a:p>
-            <a:pPr indent="0" marL="0">
+            <a:pPr marL="0" indent="0">
               <a:buNone/>
             </a:pPr>
             <a:r>
@@ -5161,7 +5379,7 @@
           <a:bodyPr wrap="square" lIns="0" tIns="0" rIns="0" bIns="0" rtlCol="0" anchor="ctr"/>
           <a:lstStyle/>
           <a:p>
-            <a:pPr indent="0" marL="0">
+            <a:pPr marL="0" indent="0">
               <a:buNone/>
             </a:pPr>
             <a:r>
@@ -5198,6 +5416,13 @@
           </a:solidFill>
           <a:ln/>
         </p:spPr>
+        <p:txBody>
+          <a:bodyPr/>
+          <a:lstStyle/>
+          <a:p>
+            <a:endParaRPr lang="en-US"/>
+          </a:p>
+        </p:txBody>
       </p:sp>
       <p:sp>
         <p:nvSpPr>
@@ -5220,7 +5445,7 @@
           <a:bodyPr wrap="square" lIns="0" tIns="0" rIns="0" bIns="0" rtlCol="0" anchor="ctr"/>
           <a:lstStyle/>
           <a:p>
-            <a:pPr indent="0" marL="0">
+            <a:pPr marL="0" indent="0">
               <a:buNone/>
             </a:pPr>
             <a:r>
@@ -5259,7 +5484,7 @@
           <a:bodyPr wrap="square" lIns="0" tIns="0" rIns="0" bIns="0" rtlCol="0" anchor="ctr"/>
           <a:lstStyle/>
           <a:p>
-            <a:pPr indent="0" marL="0">
+            <a:pPr marL="0" indent="0">
               <a:buNone/>
             </a:pPr>
             <a:r>
@@ -5287,12 +5512,13 @@
 
 <file path=ppt/slides/slide5.xml><?xml version="1.0" encoding="utf-8"?>
 <p:sld xmlns:a="http://schemas.openxmlformats.org/drawingml/2006/main" xmlns:r="http://schemas.openxmlformats.org/officeDocument/2006/relationships" xmlns:p="http://schemas.openxmlformats.org/presentationml/2006/main">
-  <p:cSld name="Slide 5">
+  <p:cSld name="Slide 4">
     <p:bg>
       <p:bgPr>
         <a:solidFill>
           <a:srgbClr val="0F1923"/>
         </a:solidFill>
+        <a:effectLst/>
       </p:bgPr>
     </p:bg>
     <p:spTree>
@@ -5328,6 +5554,13 @@
           </a:solidFill>
           <a:ln/>
         </p:spPr>
+        <p:txBody>
+          <a:bodyPr/>
+          <a:lstStyle/>
+          <a:p>
+            <a:endParaRPr lang="en-US"/>
+          </a:p>
+        </p:txBody>
       </p:sp>
       <p:sp>
         <p:nvSpPr>
@@ -5350,7 +5583,7 @@
           <a:bodyPr wrap="square" lIns="0" tIns="0" rIns="0" bIns="0" rtlCol="0" anchor="ctr"/>
           <a:lstStyle/>
           <a:p>
-            <a:pPr algn="ctr" indent="0" marL="0">
+            <a:pPr marL="0" indent="0" algn="ctr">
               <a:buNone/>
             </a:pPr>
             <a:r>
@@ -5389,7 +5622,7 @@
           <a:bodyPr wrap="square" lIns="0" tIns="0" rIns="0" bIns="0" rtlCol="0" anchor="ctr"/>
           <a:lstStyle/>
           <a:p>
-            <a:pPr indent="0" marL="0">
+            <a:pPr marL="0" indent="0">
               <a:buNone/>
             </a:pPr>
             <a:r>
@@ -5428,7 +5661,7 @@
           <a:bodyPr wrap="square" lIns="0" tIns="0" rIns="0" bIns="0" rtlCol="0" anchor="ctr"/>
           <a:lstStyle/>
           <a:p>
-            <a:pPr indent="0" marL="0">
+            <a:pPr marL="0" indent="0">
               <a:buNone/>
             </a:pPr>
             <a:r>
@@ -5440,7 +5673,7 @@
                 <a:ea typeface="Calibri" pitchFamily="34" charset="-122"/>
                 <a:cs typeface="Calibri" pitchFamily="34" charset="-120"/>
               </a:rPr>
-              <a:t>Live Streamlit app  ·  Python + scapy + Claude API  ·  github.com/dRam51/soc-triage-assistant</a:t>
+              <a:t>Live Streamlit app  ·  Python + scapy + Claude API</a:t>
             </a:r>
             <a:endParaRPr lang="en-US" sz="1050" dirty="0"/>
           </a:p>
@@ -5467,7 +5700,7 @@
           <a:bodyPr wrap="square" lIns="0" tIns="0" rIns="0" bIns="0" rtlCol="0" anchor="ctr"/>
           <a:lstStyle/>
           <a:p>
-            <a:pPr indent="0" marL="0">
+            <a:pPr marL="0" indent="0">
               <a:buNone/>
             </a:pPr>
             <a:r>
@@ -5504,6 +5737,13 @@
           </a:solidFill>
           <a:ln/>
         </p:spPr>
+        <p:txBody>
+          <a:bodyPr/>
+          <a:lstStyle/>
+          <a:p>
+            <a:endParaRPr lang="en-US"/>
+          </a:p>
+        </p:txBody>
       </p:sp>
       <p:sp>
         <p:nvSpPr>
@@ -5524,6 +5764,13 @@
           </a:solidFill>
           <a:ln/>
         </p:spPr>
+        <p:txBody>
+          <a:bodyPr/>
+          <a:lstStyle/>
+          <a:p>
+            <a:endParaRPr lang="en-US"/>
+          </a:p>
+        </p:txBody>
       </p:sp>
       <p:sp>
         <p:nvSpPr>
@@ -5546,7 +5793,7 @@
           <a:bodyPr wrap="square" lIns="0" tIns="0" rIns="0" bIns="0" rtlCol="0" anchor="ctr"/>
           <a:lstStyle/>
           <a:p>
-            <a:pPr indent="0" marL="0">
+            <a:pPr marL="0" indent="0">
               <a:buNone/>
             </a:pPr>
             <a:r>
@@ -5585,7 +5832,7 @@
           <a:bodyPr wrap="square" lIns="0" tIns="0" rIns="0" bIns="0" rtlCol="0" anchor="ctr"/>
           <a:lstStyle/>
           <a:p>
-            <a:pPr indent="0" marL="0">
+            <a:pPr marL="0" indent="0">
               <a:buNone/>
             </a:pPr>
             <a:r>
@@ -5622,6 +5869,13 @@
           </a:solidFill>
           <a:ln/>
         </p:spPr>
+        <p:txBody>
+          <a:bodyPr/>
+          <a:lstStyle/>
+          <a:p>
+            <a:endParaRPr lang="en-US"/>
+          </a:p>
+        </p:txBody>
       </p:sp>
       <p:sp>
         <p:nvSpPr>
@@ -5642,6 +5896,13 @@
           </a:solidFill>
           <a:ln/>
         </p:spPr>
+        <p:txBody>
+          <a:bodyPr/>
+          <a:lstStyle/>
+          <a:p>
+            <a:endParaRPr lang="en-US"/>
+          </a:p>
+        </p:txBody>
       </p:sp>
       <p:sp>
         <p:nvSpPr>
@@ -5664,7 +5925,7 @@
           <a:bodyPr wrap="square" lIns="0" tIns="0" rIns="0" bIns="0" rtlCol="0" anchor="ctr"/>
           <a:lstStyle/>
           <a:p>
-            <a:pPr indent="0" marL="0">
+            <a:pPr marL="0" indent="0">
               <a:buNone/>
             </a:pPr>
             <a:r>
@@ -5703,7 +5964,7 @@
           <a:bodyPr wrap="square" lIns="0" tIns="0" rIns="0" bIns="0" rtlCol="0" anchor="ctr"/>
           <a:lstStyle/>
           <a:p>
-            <a:pPr indent="0" marL="0">
+            <a:pPr marL="0" indent="0">
               <a:buNone/>
             </a:pPr>
             <a:r>
@@ -5740,6 +6001,13 @@
           </a:solidFill>
           <a:ln/>
         </p:spPr>
+        <p:txBody>
+          <a:bodyPr/>
+          <a:lstStyle/>
+          <a:p>
+            <a:endParaRPr lang="en-US"/>
+          </a:p>
+        </p:txBody>
       </p:sp>
       <p:sp>
         <p:nvSpPr>
@@ -5760,6 +6028,13 @@
           </a:solidFill>
           <a:ln/>
         </p:spPr>
+        <p:txBody>
+          <a:bodyPr/>
+          <a:lstStyle/>
+          <a:p>
+            <a:endParaRPr lang="en-US"/>
+          </a:p>
+        </p:txBody>
       </p:sp>
       <p:sp>
         <p:nvSpPr>
@@ -5782,7 +6057,7 @@
           <a:bodyPr wrap="square" lIns="0" tIns="0" rIns="0" bIns="0" rtlCol="0" anchor="ctr"/>
           <a:lstStyle/>
           <a:p>
-            <a:pPr indent="0" marL="0">
+            <a:pPr marL="0" indent="0">
               <a:buNone/>
             </a:pPr>
             <a:r>
@@ -5821,7 +6096,7 @@
           <a:bodyPr wrap="square" lIns="0" tIns="0" rIns="0" bIns="0" rtlCol="0" anchor="ctr"/>
           <a:lstStyle/>
           <a:p>
-            <a:pPr indent="0" marL="0">
+            <a:pPr marL="0" indent="0">
               <a:buNone/>
             </a:pPr>
             <a:r>
@@ -5858,6 +6133,13 @@
           </a:solidFill>
           <a:ln/>
         </p:spPr>
+        <p:txBody>
+          <a:bodyPr/>
+          <a:lstStyle/>
+          <a:p>
+            <a:endParaRPr lang="en-US"/>
+          </a:p>
+        </p:txBody>
       </p:sp>
       <p:sp>
         <p:nvSpPr>
@@ -5878,6 +6160,13 @@
           </a:solidFill>
           <a:ln/>
         </p:spPr>
+        <p:txBody>
+          <a:bodyPr/>
+          <a:lstStyle/>
+          <a:p>
+            <a:endParaRPr lang="en-US"/>
+          </a:p>
+        </p:txBody>
       </p:sp>
       <p:sp>
         <p:nvSpPr>
@@ -5900,7 +6189,7 @@
           <a:bodyPr wrap="square" lIns="0" tIns="0" rIns="0" bIns="0" rtlCol="0" anchor="ctr"/>
           <a:lstStyle/>
           <a:p>
-            <a:pPr indent="0" marL="0">
+            <a:pPr marL="0" indent="0">
               <a:buNone/>
             </a:pPr>
             <a:r>
@@ -5939,7 +6228,7 @@
           <a:bodyPr wrap="square" lIns="0" tIns="0" rIns="0" bIns="0" rtlCol="0" anchor="ctr"/>
           <a:lstStyle/>
           <a:p>
-            <a:pPr indent="0" marL="0">
+            <a:pPr marL="0" indent="0">
               <a:buNone/>
             </a:pPr>
             <a:r>
@@ -5976,6 +6265,13 @@
           </a:solidFill>
           <a:ln/>
         </p:spPr>
+        <p:txBody>
+          <a:bodyPr/>
+          <a:lstStyle/>
+          <a:p>
+            <a:endParaRPr lang="en-US"/>
+          </a:p>
+        </p:txBody>
       </p:sp>
       <p:sp>
         <p:nvSpPr>
@@ -5996,6 +6292,13 @@
           </a:solidFill>
           <a:ln/>
         </p:spPr>
+        <p:txBody>
+          <a:bodyPr/>
+          <a:lstStyle/>
+          <a:p>
+            <a:endParaRPr lang="en-US"/>
+          </a:p>
+        </p:txBody>
       </p:sp>
       <p:sp>
         <p:nvSpPr>
@@ -6018,7 +6321,7 @@
           <a:bodyPr wrap="square" lIns="0" tIns="0" rIns="0" bIns="0" rtlCol="0" anchor="ctr"/>
           <a:lstStyle/>
           <a:p>
-            <a:pPr indent="0" marL="0">
+            <a:pPr marL="0" indent="0">
               <a:buNone/>
             </a:pPr>
             <a:r>
@@ -6057,7 +6360,7 @@
           <a:bodyPr wrap="square" lIns="0" tIns="0" rIns="0" bIns="0" rtlCol="0" anchor="ctr"/>
           <a:lstStyle/>
           <a:p>
-            <a:pPr indent="0" marL="0">
+            <a:pPr marL="0" indent="0">
               <a:buNone/>
             </a:pPr>
             <a:r>
@@ -6094,6 +6397,13 @@
           </a:solidFill>
           <a:ln/>
         </p:spPr>
+        <p:txBody>
+          <a:bodyPr/>
+          <a:lstStyle/>
+          <a:p>
+            <a:endParaRPr lang="en-US"/>
+          </a:p>
+        </p:txBody>
       </p:sp>
       <p:sp>
         <p:nvSpPr>
@@ -6114,6 +6424,13 @@
           </a:solidFill>
           <a:ln/>
         </p:spPr>
+        <p:txBody>
+          <a:bodyPr/>
+          <a:lstStyle/>
+          <a:p>
+            <a:endParaRPr lang="en-US"/>
+          </a:p>
+        </p:txBody>
       </p:sp>
       <p:sp>
         <p:nvSpPr>
@@ -6136,7 +6453,7 @@
           <a:bodyPr wrap="square" lIns="0" tIns="0" rIns="0" bIns="0" rtlCol="0" anchor="ctr"/>
           <a:lstStyle/>
           <a:p>
-            <a:pPr indent="0" marL="0">
+            <a:pPr marL="0" indent="0">
               <a:buNone/>
             </a:pPr>
             <a:r>
@@ -6175,7 +6492,7 @@
           <a:bodyPr wrap="square" lIns="0" tIns="0" rIns="0" bIns="0" rtlCol="0" anchor="ctr"/>
           <a:lstStyle/>
           <a:p>
-            <a:pPr indent="0" marL="0">
+            <a:pPr marL="0" indent="0">
               <a:buNone/>
             </a:pPr>
             <a:r>
@@ -6212,6 +6529,13 @@
           </a:solidFill>
           <a:ln/>
         </p:spPr>
+        <p:txBody>
+          <a:bodyPr/>
+          <a:lstStyle/>
+          <a:p>
+            <a:endParaRPr lang="en-US"/>
+          </a:p>
+        </p:txBody>
       </p:sp>
       <p:sp>
         <p:nvSpPr>
@@ -6232,6 +6556,13 @@
           </a:solidFill>
           <a:ln/>
         </p:spPr>
+        <p:txBody>
+          <a:bodyPr/>
+          <a:lstStyle/>
+          <a:p>
+            <a:endParaRPr lang="en-US"/>
+          </a:p>
+        </p:txBody>
       </p:sp>
       <p:sp>
         <p:nvSpPr>
@@ -6254,7 +6585,7 @@
           <a:bodyPr wrap="square" lIns="0" tIns="0" rIns="0" bIns="0" rtlCol="0" anchor="ctr"/>
           <a:lstStyle/>
           <a:p>
-            <a:pPr indent="0" marL="0">
+            <a:pPr marL="0" indent="0">
               <a:buNone/>
             </a:pPr>
             <a:r>
@@ -6293,7 +6624,7 @@
           <a:bodyPr wrap="square" lIns="0" tIns="0" rIns="0" bIns="0" rtlCol="0" anchor="ctr"/>
           <a:lstStyle/>
           <a:p>
-            <a:pPr indent="0" marL="0">
+            <a:pPr marL="0" indent="0">
               <a:buNone/>
             </a:pPr>
             <a:r>
@@ -6330,13 +6661,20 @@
           </a:solidFill>
           <a:ln/>
           <a:effectLst>
-            <a:outerShdw sx="100000" sy="100000" kx="0" ky="0" algn="bl" rotWithShape="0" blurRad="127000" dist="50800" dir="8100000">
+            <a:outerShdw blurRad="127000" dist="50800" dir="8100000" algn="bl" rotWithShape="0">
               <a:srgbClr val="000000">
                 <a:alpha val="28000"/>
               </a:srgbClr>
             </a:outerShdw>
           </a:effectLst>
         </p:spPr>
+        <p:txBody>
+          <a:bodyPr/>
+          <a:lstStyle/>
+          <a:p>
+            <a:endParaRPr lang="en-US"/>
+          </a:p>
+        </p:txBody>
       </p:sp>
       <p:sp>
         <p:nvSpPr>
@@ -6357,6 +6695,13 @@
           </a:solidFill>
           <a:ln/>
         </p:spPr>
+        <p:txBody>
+          <a:bodyPr/>
+          <a:lstStyle/>
+          <a:p>
+            <a:endParaRPr lang="en-US"/>
+          </a:p>
+        </p:txBody>
       </p:sp>
       <p:sp>
         <p:nvSpPr>
@@ -6379,7 +6724,7 @@
           <a:bodyPr wrap="square" lIns="0" tIns="0" rIns="0" bIns="0" rtlCol="0" anchor="ctr"/>
           <a:lstStyle/>
           <a:p>
-            <a:pPr indent="0" marL="0">
+            <a:pPr marL="0" indent="0">
               <a:buNone/>
             </a:pPr>
             <a:r>
@@ -6416,6 +6761,13 @@
           </a:solidFill>
           <a:ln/>
         </p:spPr>
+        <p:txBody>
+          <a:bodyPr/>
+          <a:lstStyle/>
+          <a:p>
+            <a:endParaRPr lang="en-US"/>
+          </a:p>
+        </p:txBody>
       </p:sp>
       <p:sp>
         <p:nvSpPr>
@@ -6438,7 +6790,7 @@
           <a:bodyPr wrap="square" lIns="0" tIns="0" rIns="0" bIns="0" rtlCol="0" anchor="ctr"/>
           <a:lstStyle/>
           <a:p>
-            <a:pPr indent="0" marL="0">
+            <a:pPr marL="0" indent="0">
               <a:buNone/>
             </a:pPr>
             <a:r>
@@ -6477,7 +6829,7 @@
           <a:bodyPr wrap="square" lIns="0" tIns="0" rIns="0" bIns="0" rtlCol="0" anchor="ctr"/>
           <a:lstStyle/>
           <a:p>
-            <a:pPr indent="0" marL="0">
+            <a:pPr marL="0" indent="0">
               <a:buNone/>
             </a:pPr>
             <a:r>
@@ -6514,6 +6866,13 @@
           </a:solidFill>
           <a:ln/>
         </p:spPr>
+        <p:txBody>
+          <a:bodyPr/>
+          <a:lstStyle/>
+          <a:p>
+            <a:endParaRPr lang="en-US"/>
+          </a:p>
+        </p:txBody>
       </p:sp>
       <p:sp>
         <p:nvSpPr>
@@ -6523,20 +6882,20 @@
         </p:nvSpPr>
         <p:spPr>
           <a:xfrm>
-            <a:off x="7918704" y="1847088"/>
-            <a:ext cx="685800" cy="402336"/>
-          </a:xfrm>
-          <a:prstGeom prst="rect">
-            <a:avLst/>
-          </a:prstGeom>
-          <a:noFill/>
-          <a:ln/>
-        </p:spPr>
-        <p:txBody>
-          <a:bodyPr wrap="square" lIns="0" tIns="0" rIns="0" bIns="0" rtlCol="0" anchor="ctr"/>
-          <a:lstStyle/>
-          <a:p>
-            <a:pPr algn="ctr" indent="0" marL="0">
+            <a:off x="8014716" y="1847088"/>
+            <a:ext cx="493776" cy="292608"/>
+          </a:xfrm>
+          <a:prstGeom prst="rect">
+            <a:avLst/>
+          </a:prstGeom>
+          <a:noFill/>
+          <a:ln/>
+        </p:spPr>
+        <p:txBody>
+          <a:bodyPr wrap="square" lIns="0" tIns="0" rIns="0" bIns="0" rtlCol="0" anchor="ctr"/>
+          <a:lstStyle/>
+          <a:p>
+            <a:pPr marL="0" indent="0" algn="ctr">
               <a:buNone/>
             </a:pPr>
             <a:r>
@@ -6573,6 +6932,13 @@
           </a:solidFill>
           <a:ln/>
         </p:spPr>
+        <p:txBody>
+          <a:bodyPr/>
+          <a:lstStyle/>
+          <a:p>
+            <a:endParaRPr lang="en-US"/>
+          </a:p>
+        </p:txBody>
       </p:sp>
       <p:sp>
         <p:nvSpPr>
@@ -6595,7 +6961,7 @@
           <a:bodyPr wrap="square" lIns="0" tIns="0" rIns="0" bIns="0" rtlCol="0" anchor="t"/>
           <a:lstStyle/>
           <a:p>
-            <a:pPr indent="0" marL="0">
+            <a:pPr marL="0" indent="0">
               <a:buNone/>
             </a:pPr>
             <a:r>
@@ -6632,6 +6998,13 @@
           </a:solidFill>
           <a:ln/>
         </p:spPr>
+        <p:txBody>
+          <a:bodyPr/>
+          <a:lstStyle/>
+          <a:p>
+            <a:endParaRPr lang="en-US"/>
+          </a:p>
+        </p:txBody>
       </p:sp>
       <p:sp>
         <p:nvSpPr>
@@ -6654,7 +7027,7 @@
           <a:bodyPr wrap="square" lIns="0" tIns="0" rIns="0" bIns="0" rtlCol="0" anchor="ctr"/>
           <a:lstStyle/>
           <a:p>
-            <a:pPr indent="0" marL="0">
+            <a:pPr marL="0" indent="0">
               <a:buNone/>
             </a:pPr>
             <a:r>
@@ -6693,7 +7066,7 @@
           <a:bodyPr wrap="square" lIns="0" tIns="0" rIns="0" bIns="0" rtlCol="0" anchor="ctr"/>
           <a:lstStyle/>
           <a:p>
-            <a:pPr indent="0" marL="0">
+            <a:pPr marL="0" indent="0">
               <a:buNone/>
             </a:pPr>
             <a:r>
@@ -6730,6 +7103,13 @@
           </a:solidFill>
           <a:ln/>
         </p:spPr>
+        <p:txBody>
+          <a:bodyPr/>
+          <a:lstStyle/>
+          <a:p>
+            <a:endParaRPr lang="en-US"/>
+          </a:p>
+        </p:txBody>
       </p:sp>
       <p:sp>
         <p:nvSpPr>
@@ -6750,6 +7130,13 @@
           </a:solidFill>
           <a:ln/>
         </p:spPr>
+        <p:txBody>
+          <a:bodyPr/>
+          <a:lstStyle/>
+          <a:p>
+            <a:endParaRPr lang="en-US"/>
+          </a:p>
+        </p:txBody>
       </p:sp>
       <p:sp>
         <p:nvSpPr>
@@ -6772,7 +7159,7 @@
           <a:bodyPr wrap="square" lIns="0" tIns="0" rIns="0" bIns="0" rtlCol="0" anchor="ctr"/>
           <a:lstStyle/>
           <a:p>
-            <a:pPr indent="0" marL="0">
+            <a:pPr marL="0" indent="0">
               <a:buNone/>
             </a:pPr>
             <a:r>
@@ -6811,7 +7198,7 @@
           <a:bodyPr wrap="square" lIns="0" tIns="0" rIns="0" bIns="0" rtlCol="0" anchor="ctr"/>
           <a:lstStyle/>
           <a:p>
-            <a:pPr indent="0" marL="0">
+            <a:pPr marL="0" indent="0">
               <a:buNone/>
             </a:pPr>
             <a:r>
@@ -6848,6 +7235,13 @@
           </a:solidFill>
           <a:ln/>
         </p:spPr>
+        <p:txBody>
+          <a:bodyPr/>
+          <a:lstStyle/>
+          <a:p>
+            <a:endParaRPr lang="en-US"/>
+          </a:p>
+        </p:txBody>
       </p:sp>
       <p:sp>
         <p:nvSpPr>
@@ -6868,6 +7262,13 @@
           </a:solidFill>
           <a:ln/>
         </p:spPr>
+        <p:txBody>
+          <a:bodyPr/>
+          <a:lstStyle/>
+          <a:p>
+            <a:endParaRPr lang="en-US"/>
+          </a:p>
+        </p:txBody>
       </p:sp>
       <p:sp>
         <p:nvSpPr>
@@ -6890,7 +7291,7 @@
           <a:bodyPr wrap="square" lIns="0" tIns="0" rIns="0" bIns="0" rtlCol="0" anchor="ctr"/>
           <a:lstStyle/>
           <a:p>
-            <a:pPr indent="0" marL="0">
+            <a:pPr marL="0" indent="0">
               <a:buNone/>
             </a:pPr>
             <a:r>
@@ -6929,7 +7330,7 @@
           <a:bodyPr wrap="square" lIns="0" tIns="0" rIns="0" bIns="0" rtlCol="0" anchor="ctr"/>
           <a:lstStyle/>
           <a:p>
-            <a:pPr indent="0" marL="0">
+            <a:pPr marL="0" indent="0">
               <a:buNone/>
             </a:pPr>
             <a:r>
@@ -6966,6 +7367,13 @@
           </a:solidFill>
           <a:ln/>
         </p:spPr>
+        <p:txBody>
+          <a:bodyPr/>
+          <a:lstStyle/>
+          <a:p>
+            <a:endParaRPr lang="en-US"/>
+          </a:p>
+        </p:txBody>
       </p:sp>
       <p:sp>
         <p:nvSpPr>
@@ -6986,6 +7394,13 @@
           </a:solidFill>
           <a:ln/>
         </p:spPr>
+        <p:txBody>
+          <a:bodyPr/>
+          <a:lstStyle/>
+          <a:p>
+            <a:endParaRPr lang="en-US"/>
+          </a:p>
+        </p:txBody>
       </p:sp>
       <p:sp>
         <p:nvSpPr>
@@ -7008,7 +7423,7 @@
           <a:bodyPr wrap="square" lIns="0" tIns="0" rIns="0" bIns="0" rtlCol="0" anchor="ctr"/>
           <a:lstStyle/>
           <a:p>
-            <a:pPr indent="0" marL="0">
+            <a:pPr marL="0" indent="0">
               <a:buNone/>
             </a:pPr>
             <a:r>
@@ -7047,7 +7462,7 @@
           <a:bodyPr wrap="square" lIns="0" tIns="0" rIns="0" bIns="0" rtlCol="0" anchor="ctr"/>
           <a:lstStyle/>
           <a:p>
-            <a:pPr indent="0" marL="0">
+            <a:pPr marL="0" indent="0">
               <a:buNone/>
             </a:pPr>
             <a:r>
@@ -7084,6 +7499,13 @@
           </a:solidFill>
           <a:ln/>
         </p:spPr>
+        <p:txBody>
+          <a:bodyPr/>
+          <a:lstStyle/>
+          <a:p>
+            <a:endParaRPr lang="en-US"/>
+          </a:p>
+        </p:txBody>
       </p:sp>
       <p:sp>
         <p:nvSpPr>
@@ -7104,6 +7526,13 @@
           </a:solidFill>
           <a:ln/>
         </p:spPr>
+        <p:txBody>
+          <a:bodyPr/>
+          <a:lstStyle/>
+          <a:p>
+            <a:endParaRPr lang="en-US"/>
+          </a:p>
+        </p:txBody>
       </p:sp>
       <p:sp>
         <p:nvSpPr>
@@ -7126,7 +7555,7 @@
           <a:bodyPr wrap="square" lIns="0" tIns="0" rIns="0" bIns="0" rtlCol="0" anchor="ctr"/>
           <a:lstStyle/>
           <a:p>
-            <a:pPr indent="0" marL="0">
+            <a:pPr marL="0" indent="0">
               <a:buNone/>
             </a:pPr>
             <a:r>
@@ -7165,7 +7594,7 @@
           <a:bodyPr wrap="square" lIns="0" tIns="0" rIns="0" bIns="0" rtlCol="0" anchor="ctr"/>
           <a:lstStyle/>
           <a:p>
-            <a:pPr indent="0" marL="0">
+            <a:pPr marL="0" indent="0">
               <a:buNone/>
             </a:pPr>
             <a:r>
@@ -7204,7 +7633,7 @@
           <a:bodyPr wrap="square" lIns="0" tIns="0" rIns="0" bIns="0" rtlCol="0" anchor="ctr"/>
           <a:lstStyle/>
           <a:p>
-            <a:pPr indent="0" marL="0">
+            <a:pPr marL="0" indent="0">
               <a:buNone/>
             </a:pPr>
             <a:r>
@@ -7241,6 +7670,13 @@
           </a:solidFill>
           <a:ln/>
         </p:spPr>
+        <p:txBody>
+          <a:bodyPr/>
+          <a:lstStyle/>
+          <a:p>
+            <a:endParaRPr lang="en-US"/>
+          </a:p>
+        </p:txBody>
       </p:sp>
       <p:sp>
         <p:nvSpPr>
@@ -7263,7 +7699,7 @@
           <a:bodyPr wrap="square" lIns="0" tIns="0" rIns="0" bIns="0" rtlCol="0" anchor="ctr"/>
           <a:lstStyle/>
           <a:p>
-            <a:pPr algn="ctr" indent="0" marL="0">
+            <a:pPr marL="0" indent="0" algn="ctr">
               <a:buNone/>
             </a:pPr>
             <a:r>
@@ -7300,6 +7736,13 @@
           </a:solidFill>
           <a:ln/>
         </p:spPr>
+        <p:txBody>
+          <a:bodyPr/>
+          <a:lstStyle/>
+          <a:p>
+            <a:endParaRPr lang="en-US"/>
+          </a:p>
+        </p:txBody>
       </p:sp>
       <p:sp>
         <p:nvSpPr>
@@ -7322,7 +7765,7 @@
           <a:bodyPr wrap="square" lIns="0" tIns="0" rIns="0" bIns="0" rtlCol="0" anchor="ctr"/>
           <a:lstStyle/>
           <a:p>
-            <a:pPr algn="ctr" indent="0" marL="0">
+            <a:pPr marL="0" indent="0" algn="ctr">
               <a:buNone/>
             </a:pPr>
             <a:r>
@@ -7359,6 +7802,13 @@
           </a:solidFill>
           <a:ln/>
         </p:spPr>
+        <p:txBody>
+          <a:bodyPr/>
+          <a:lstStyle/>
+          <a:p>
+            <a:endParaRPr lang="en-US"/>
+          </a:p>
+        </p:txBody>
       </p:sp>
       <p:sp>
         <p:nvSpPr>
@@ -7381,7 +7831,7 @@
           <a:bodyPr wrap="square" lIns="0" tIns="0" rIns="0" bIns="0" rtlCol="0" anchor="ctr"/>
           <a:lstStyle/>
           <a:p>
-            <a:pPr algn="ctr" indent="0" marL="0">
+            <a:pPr marL="0" indent="0" algn="ctr">
               <a:buNone/>
             </a:pPr>
             <a:r>
@@ -7700,4 +8150,319 @@
     </a:ext>
   </a:extLst>
 </a:theme>
+</file>
+
+<file path=ppt/theme/theme2.xml><?xml version="1.0" encoding="utf-8"?>
+<a:theme xmlns:a="http://schemas.openxmlformats.org/drawingml/2006/main" name="Office Theme">
+  <a:themeElements>
+    <a:clrScheme name="Office">
+      <a:dk1>
+        <a:sysClr val="windowText" lastClr="000000"/>
+      </a:dk1>
+      <a:lt1>
+        <a:sysClr val="window" lastClr="FFFFFF"/>
+      </a:lt1>
+      <a:dk2>
+        <a:srgbClr val="0E2841"/>
+      </a:dk2>
+      <a:lt2>
+        <a:srgbClr val="E8E8E8"/>
+      </a:lt2>
+      <a:accent1>
+        <a:srgbClr val="156082"/>
+      </a:accent1>
+      <a:accent2>
+        <a:srgbClr val="E97132"/>
+      </a:accent2>
+      <a:accent3>
+        <a:srgbClr val="196B24"/>
+      </a:accent3>
+      <a:accent4>
+        <a:srgbClr val="0F9ED5"/>
+      </a:accent4>
+      <a:accent5>
+        <a:srgbClr val="A02B93"/>
+      </a:accent5>
+      <a:accent6>
+        <a:srgbClr val="4EA72E"/>
+      </a:accent6>
+      <a:hlink>
+        <a:srgbClr val="467886"/>
+      </a:hlink>
+      <a:folHlink>
+        <a:srgbClr val="96607D"/>
+      </a:folHlink>
+    </a:clrScheme>
+    <a:fontScheme name="Office">
+      <a:majorFont>
+        <a:latin typeface="Aptos Display" panose="02110004020202020204"/>
+        <a:ea typeface=""/>
+        <a:cs typeface=""/>
+        <a:font script="Jpan" typeface="游ゴシック Light"/>
+        <a:font script="Hang" typeface="맑은 고딕"/>
+        <a:font script="Hans" typeface="等线 Light"/>
+        <a:font script="Hant" typeface="新細明體"/>
+        <a:font script="Arab" typeface="Times New Roman"/>
+        <a:font script="Hebr" typeface="Times New Roman"/>
+        <a:font script="Thai" typeface="Angsana New"/>
+        <a:font script="Ethi" typeface="Nyala"/>
+        <a:font script="Beng" typeface="Vrinda"/>
+        <a:font script="Gujr" typeface="Shruti"/>
+        <a:font script="Khmr" typeface="MoolBoran"/>
+        <a:font script="Knda" typeface="Tunga"/>
+        <a:font script="Guru" typeface="Raavi"/>
+        <a:font script="Cans" typeface="Euphemia"/>
+        <a:font script="Cher" typeface="Plantagenet Cherokee"/>
+        <a:font script="Yiii" typeface="Microsoft Yi Baiti"/>
+        <a:font script="Tibt" typeface="Microsoft Himalaya"/>
+        <a:font script="Thaa" typeface="MV Boli"/>
+        <a:font script="Deva" typeface="Mangal"/>
+        <a:font script="Telu" typeface="Gautami"/>
+        <a:font script="Taml" typeface="Latha"/>
+        <a:font script="Syrc" typeface="Estrangelo Edessa"/>
+        <a:font script="Orya" typeface="Kalinga"/>
+        <a:font script="Mlym" typeface="Kartika"/>
+        <a:font script="Laoo" typeface="DokChampa"/>
+        <a:font script="Sinh" typeface="Iskoola Pota"/>
+        <a:font script="Mong" typeface="Mongolian Baiti"/>
+        <a:font script="Viet" typeface="Times New Roman"/>
+        <a:font script="Uigh" typeface="Microsoft Uighur"/>
+        <a:font script="Geor" typeface="Sylfaen"/>
+        <a:font script="Armn" typeface="Arial"/>
+        <a:font script="Bugi" typeface="Leelawadee UI"/>
+        <a:font script="Bopo" typeface="Microsoft JhengHei"/>
+        <a:font script="Java" typeface="Javanese Text"/>
+        <a:font script="Lisu" typeface="Segoe UI"/>
+        <a:font script="Mymr" typeface="Myanmar Text"/>
+        <a:font script="Nkoo" typeface="Ebrima"/>
+        <a:font script="Olck" typeface="Nirmala UI"/>
+        <a:font script="Osma" typeface="Ebrima"/>
+        <a:font script="Phag" typeface="Phagspa"/>
+        <a:font script="Syrn" typeface="Estrangelo Edessa"/>
+        <a:font script="Syrj" typeface="Estrangelo Edessa"/>
+        <a:font script="Syre" typeface="Estrangelo Edessa"/>
+        <a:font script="Sora" typeface="Nirmala UI"/>
+        <a:font script="Tale" typeface="Microsoft Tai Le"/>
+        <a:font script="Talu" typeface="Microsoft New Tai Lue"/>
+        <a:font script="Tfng" typeface="Ebrima"/>
+      </a:majorFont>
+      <a:minorFont>
+        <a:latin typeface="Aptos" panose="02110004020202020204"/>
+        <a:ea typeface=""/>
+        <a:cs typeface=""/>
+        <a:font script="Jpan" typeface="游ゴシック"/>
+        <a:font script="Hang" typeface="맑은 고딕"/>
+        <a:font script="Hans" typeface="等线"/>
+        <a:font script="Hant" typeface="新細明體"/>
+        <a:font script="Arab" typeface="Arial"/>
+        <a:font script="Hebr" typeface="Arial"/>
+        <a:font script="Thai" typeface="Cordia New"/>
+        <a:font script="Ethi" typeface="Nyala"/>
+        <a:font script="Beng" typeface="Vrinda"/>
+        <a:font script="Gujr" typeface="Shruti"/>
+        <a:font script="Khmr" typeface="DaunPenh"/>
+        <a:font script="Knda" typeface="Tunga"/>
+        <a:font script="Guru" typeface="Raavi"/>
+        <a:font script="Cans" typeface="Euphemia"/>
+        <a:font script="Cher" typeface="Plantagenet Cherokee"/>
+        <a:font script="Yiii" typeface="Microsoft Yi Baiti"/>
+        <a:font script="Tibt" typeface="Microsoft Himalaya"/>
+        <a:font script="Thaa" typeface="MV Boli"/>
+        <a:font script="Deva" typeface="Mangal"/>
+        <a:font script="Telu" typeface="Gautami"/>
+        <a:font script="Taml" typeface="Latha"/>
+        <a:font script="Syrc" typeface="Estrangelo Edessa"/>
+        <a:font script="Orya" typeface="Kalinga"/>
+        <a:font script="Mlym" typeface="Kartika"/>
+        <a:font script="Laoo" typeface="DokChampa"/>
+        <a:font script="Sinh" typeface="Iskoola Pota"/>
+        <a:font script="Mong" typeface="Mongolian Baiti"/>
+        <a:font script="Viet" typeface="Arial"/>
+        <a:font script="Uigh" typeface="Microsoft Uighur"/>
+        <a:font script="Geor" typeface="Sylfaen"/>
+        <a:font script="Armn" typeface="Arial"/>
+        <a:font script="Bugi" typeface="Leelawadee UI"/>
+        <a:font script="Bopo" typeface="Microsoft JhengHei"/>
+        <a:font script="Java" typeface="Javanese Text"/>
+        <a:font script="Lisu" typeface="Segoe UI"/>
+        <a:font script="Mymr" typeface="Myanmar Text"/>
+        <a:font script="Nkoo" typeface="Ebrima"/>
+        <a:font script="Olck" typeface="Nirmala UI"/>
+        <a:font script="Osma" typeface="Ebrima"/>
+        <a:font script="Phag" typeface="Phagspa"/>
+        <a:font script="Syrn" typeface="Estrangelo Edessa"/>
+        <a:font script="Syrj" typeface="Estrangelo Edessa"/>
+        <a:font script="Syre" typeface="Estrangelo Edessa"/>
+        <a:font script="Sora" typeface="Nirmala UI"/>
+        <a:font script="Tale" typeface="Microsoft Tai Le"/>
+        <a:font script="Talu" typeface="Microsoft New Tai Lue"/>
+        <a:font script="Tfng" typeface="Ebrima"/>
+      </a:minorFont>
+    </a:fontScheme>
+    <a:fmtScheme name="Office">
+      <a:fillStyleLst>
+        <a:solidFill>
+          <a:schemeClr val="phClr"/>
+        </a:solidFill>
+        <a:gradFill rotWithShape="1">
+          <a:gsLst>
+            <a:gs pos="0">
+              <a:schemeClr val="phClr">
+                <a:lumMod val="110000"/>
+                <a:satMod val="105000"/>
+                <a:tint val="67000"/>
+              </a:schemeClr>
+            </a:gs>
+            <a:gs pos="50000">
+              <a:schemeClr val="phClr">
+                <a:lumMod val="105000"/>
+                <a:satMod val="103000"/>
+                <a:tint val="73000"/>
+              </a:schemeClr>
+            </a:gs>
+            <a:gs pos="100000">
+              <a:schemeClr val="phClr">
+                <a:lumMod val="105000"/>
+                <a:satMod val="109000"/>
+                <a:tint val="81000"/>
+              </a:schemeClr>
+            </a:gs>
+          </a:gsLst>
+          <a:lin ang="5400000" scaled="0"/>
+        </a:gradFill>
+        <a:gradFill rotWithShape="1">
+          <a:gsLst>
+            <a:gs pos="0">
+              <a:schemeClr val="phClr">
+                <a:satMod val="103000"/>
+                <a:lumMod val="102000"/>
+                <a:tint val="94000"/>
+              </a:schemeClr>
+            </a:gs>
+            <a:gs pos="50000">
+              <a:schemeClr val="phClr">
+                <a:satMod val="110000"/>
+                <a:lumMod val="100000"/>
+                <a:shade val="100000"/>
+              </a:schemeClr>
+            </a:gs>
+            <a:gs pos="100000">
+              <a:schemeClr val="phClr">
+                <a:lumMod val="99000"/>
+                <a:satMod val="120000"/>
+                <a:shade val="78000"/>
+              </a:schemeClr>
+            </a:gs>
+          </a:gsLst>
+          <a:lin ang="5400000" scaled="0"/>
+        </a:gradFill>
+      </a:fillStyleLst>
+      <a:lnStyleLst>
+        <a:ln w="12700" cap="flat" cmpd="sng" algn="ctr">
+          <a:solidFill>
+            <a:schemeClr val="phClr"/>
+          </a:solidFill>
+          <a:prstDash val="solid"/>
+          <a:miter lim="800000"/>
+        </a:ln>
+        <a:ln w="19050" cap="flat" cmpd="sng" algn="ctr">
+          <a:solidFill>
+            <a:schemeClr val="phClr"/>
+          </a:solidFill>
+          <a:prstDash val="solid"/>
+          <a:miter lim="800000"/>
+        </a:ln>
+        <a:ln w="25400" cap="flat" cmpd="sng" algn="ctr">
+          <a:solidFill>
+            <a:schemeClr val="phClr"/>
+          </a:solidFill>
+          <a:prstDash val="solid"/>
+          <a:miter lim="800000"/>
+        </a:ln>
+      </a:lnStyleLst>
+      <a:effectStyleLst>
+        <a:effectStyle>
+          <a:effectLst/>
+        </a:effectStyle>
+        <a:effectStyle>
+          <a:effectLst/>
+        </a:effectStyle>
+        <a:effectStyle>
+          <a:effectLst>
+            <a:outerShdw blurRad="57150" dist="19050" dir="5400000" algn="ctr" rotWithShape="0">
+              <a:srgbClr val="000000">
+                <a:alpha val="63000"/>
+              </a:srgbClr>
+            </a:outerShdw>
+          </a:effectLst>
+        </a:effectStyle>
+      </a:effectStyleLst>
+      <a:bgFillStyleLst>
+        <a:solidFill>
+          <a:schemeClr val="phClr"/>
+        </a:solidFill>
+        <a:solidFill>
+          <a:schemeClr val="phClr">
+            <a:tint val="95000"/>
+            <a:satMod val="170000"/>
+          </a:schemeClr>
+        </a:solidFill>
+        <a:gradFill rotWithShape="1">
+          <a:gsLst>
+            <a:gs pos="0">
+              <a:schemeClr val="phClr">
+                <a:tint val="93000"/>
+                <a:satMod val="150000"/>
+                <a:shade val="98000"/>
+                <a:lumMod val="102000"/>
+              </a:schemeClr>
+            </a:gs>
+            <a:gs pos="50000">
+              <a:schemeClr val="phClr">
+                <a:tint val="98000"/>
+                <a:satMod val="130000"/>
+                <a:shade val="90000"/>
+                <a:lumMod val="103000"/>
+              </a:schemeClr>
+            </a:gs>
+            <a:gs pos="100000">
+              <a:schemeClr val="phClr">
+                <a:shade val="63000"/>
+                <a:satMod val="120000"/>
+              </a:schemeClr>
+            </a:gs>
+          </a:gsLst>
+          <a:lin ang="5400000" scaled="0"/>
+        </a:gradFill>
+      </a:bgFillStyleLst>
+    </a:fmtScheme>
+  </a:themeElements>
+  <a:objectDefaults>
+    <a:lnDef>
+      <a:spPr/>
+      <a:bodyPr/>
+      <a:lstStyle/>
+      <a:style>
+        <a:lnRef idx="2">
+          <a:schemeClr val="accent1"/>
+        </a:lnRef>
+        <a:fillRef idx="0">
+          <a:schemeClr val="accent1"/>
+        </a:fillRef>
+        <a:effectRef idx="1">
+          <a:schemeClr val="accent1"/>
+        </a:effectRef>
+        <a:fontRef idx="minor">
+          <a:schemeClr val="tx1"/>
+        </a:fontRef>
+      </a:style>
+    </a:lnDef>
+  </a:objectDefaults>
+  <a:extraClrSchemeLst/>
+  <a:extLst>
+    <a:ext uri="{05A4C25C-085E-4340-85A3-A5531E510DB2}">
+      <thm15:themeFamily xmlns:thm15="http://schemas.microsoft.com/office/thememl/2012/main" name="Office Theme" id="{2E142A2C-CD16-42D6-873A-C26D2A0506FA}" vid="{1BDDFF52-6CD6-40A5-AB3C-68EB2F1E4D0A}"/>
+    </a:ext>
+  </a:extLst>
+</a:theme>
 </file>
</xml_diff>